<commit_message>
fix: Arreglos estéticos y lógicos
</commit_message>
<xml_diff>
--- a/TFG_Chollos/Presentacion_Defensa_TFG.pptx
+++ b/TFG_Chollos/Presentacion_Defensa_TFG.pptx
@@ -13584,7 +13584,7 @@
           <p:nvPr>
             <p:extLst>
               <p:ext uri="{D42A27DB-BD31-4B8C-83A1-F6EECF244321}">
-                <p14:modId xmlns:p14="http://schemas.microsoft.com/office/powerpoint/2010/main" val="1340273364"/>
+                <p14:modId xmlns:p14="http://schemas.microsoft.com/office/powerpoint/2010/main" val="830664776"/>
               </p:ext>
             </p:extLst>
           </p:nvPr>
@@ -13971,7 +13971,9 @@
                       <a:tailEnd type="none" w="med" len="med"/>
                     </a:lnB>
                     <a:solidFill>
-                      <a:srgbClr val="D99A3D"/>
+                      <a:schemeClr val="accent6">
+                        <a:lumMod val="50000"/>
+                      </a:schemeClr>
                     </a:solidFill>
                   </a:tcPr>
                 </a:tc>
@@ -13986,7 +13988,7 @@
                       <a:r>
                         <a:rPr lang="en-US" sz="1250" b="1" dirty="0">
                           <a:solidFill>
-                            <a:srgbClr val="2B2320"/>
+                            <a:schemeClr val="bg1"/>
                           </a:solidFill>
                           <a:latin typeface="Calibri" pitchFamily="34" charset="0"/>
                           <a:ea typeface="Calibri" pitchFamily="34" charset="-122"/>
@@ -13995,6 +13997,9 @@
                         <a:t>Hiper-chollo</a:t>
                       </a:r>
                       <a:endParaRPr lang="en-US" sz="1250" dirty="0">
+                        <a:solidFill>
+                          <a:schemeClr val="bg1"/>
+                        </a:solidFill>
                         <a:latin typeface="Calibri" charset="0"/>
                         <a:ea typeface="Calibri" charset="0"/>
                         <a:cs typeface="Calibri" charset="0"/>
@@ -14039,7 +14044,9 @@
                       <a:tailEnd type="none" w="med" len="med"/>
                     </a:lnB>
                     <a:solidFill>
-                      <a:srgbClr val="D99A3D"/>
+                      <a:schemeClr val="accent6">
+                        <a:lumMod val="50000"/>
+                      </a:schemeClr>
                     </a:solidFill>
                   </a:tcPr>
                 </a:tc>
@@ -14054,7 +14061,7 @@
                       <a:r>
                         <a:rPr lang="en-US" sz="1250" dirty="0">
                           <a:solidFill>
-                            <a:srgbClr val="2B2320"/>
+                            <a:schemeClr val="bg1"/>
                           </a:solidFill>
                           <a:latin typeface="Calibri" pitchFamily="34" charset="0"/>
                           <a:ea typeface="Calibri" pitchFamily="34" charset="-122"/>
@@ -14063,6 +14070,9 @@
                         <a:t>r ≤ 0,75</a:t>
                       </a:r>
                       <a:endParaRPr lang="en-US" sz="1250" dirty="0">
+                        <a:solidFill>
+                          <a:schemeClr val="bg1"/>
+                        </a:solidFill>
                         <a:latin typeface="Calibri" charset="0"/>
                         <a:ea typeface="Calibri" charset="0"/>
                         <a:cs typeface="Calibri" charset="0"/>
@@ -14107,7 +14117,9 @@
                       <a:tailEnd type="none" w="med" len="med"/>
                     </a:lnB>
                     <a:solidFill>
-                      <a:srgbClr val="D99A3D"/>
+                      <a:schemeClr val="accent6">
+                        <a:lumMod val="50000"/>
+                      </a:schemeClr>
                     </a:solidFill>
                   </a:tcPr>
                 </a:tc>
@@ -14122,7 +14134,7 @@
                       <a:r>
                         <a:rPr lang="en-US" sz="1100" dirty="0">
                           <a:solidFill>
-                            <a:srgbClr val="2B2320"/>
+                            <a:schemeClr val="bg1"/>
                           </a:solidFill>
                           <a:latin typeface="Calibri" pitchFamily="34" charset="0"/>
                           <a:ea typeface="Calibri" pitchFamily="34" charset="-122"/>
@@ -14131,6 +14143,9 @@
                         <a:t>≥25% por debajo del precio justo</a:t>
                       </a:r>
                       <a:endParaRPr lang="en-US" sz="1100" dirty="0">
+                        <a:solidFill>
+                          <a:schemeClr val="bg1"/>
+                        </a:solidFill>
                         <a:latin typeface="Calibri" charset="0"/>
                         <a:ea typeface="Calibri" charset="0"/>
                         <a:cs typeface="Calibri" charset="0"/>
@@ -14175,7 +14190,9 @@
                       <a:tailEnd type="none" w="med" len="med"/>
                     </a:lnB>
                     <a:solidFill>
-                      <a:srgbClr val="D99A3D"/>
+                      <a:schemeClr val="accent6">
+                        <a:lumMod val="50000"/>
+                      </a:schemeClr>
                     </a:solidFill>
                   </a:tcPr>
                 </a:tc>
@@ -14250,7 +14267,9 @@
                       <a:tailEnd type="none" w="med" len="med"/>
                     </a:lnB>
                     <a:solidFill>
-                      <a:srgbClr val="FFFFFF"/>
+                      <a:schemeClr val="accent6">
+                        <a:lumMod val="75000"/>
+                      </a:schemeClr>
                     </a:solidFill>
                   </a:tcPr>
                 </a:tc>
@@ -14318,7 +14337,9 @@
                       <a:tailEnd type="none" w="med" len="med"/>
                     </a:lnB>
                     <a:solidFill>
-                      <a:srgbClr val="3B6E77"/>
+                      <a:schemeClr val="accent6">
+                        <a:lumMod val="75000"/>
+                      </a:schemeClr>
                     </a:solidFill>
                   </a:tcPr>
                 </a:tc>
@@ -14386,7 +14407,9 @@
                       <a:tailEnd type="none" w="med" len="med"/>
                     </a:lnB>
                     <a:solidFill>
-                      <a:srgbClr val="3B6E77"/>
+                      <a:schemeClr val="accent6">
+                        <a:lumMod val="75000"/>
+                      </a:schemeClr>
                     </a:solidFill>
                   </a:tcPr>
                 </a:tc>
@@ -14454,7 +14477,9 @@
                       <a:tailEnd type="none" w="med" len="med"/>
                     </a:lnB>
                     <a:solidFill>
-                      <a:srgbClr val="3B6E77"/>
+                      <a:schemeClr val="accent6">
+                        <a:lumMod val="75000"/>
+                      </a:schemeClr>
                     </a:solidFill>
                   </a:tcPr>
                 </a:tc>
@@ -14529,7 +14554,10 @@
                       <a:tailEnd type="none" w="med" len="med"/>
                     </a:lnB>
                     <a:solidFill>
-                      <a:srgbClr val="8FB7AE"/>
+                      <a:schemeClr val="accent6">
+                        <a:lumMod val="60000"/>
+                        <a:lumOff val="40000"/>
+                      </a:schemeClr>
                     </a:solidFill>
                   </a:tcPr>
                 </a:tc>
@@ -14544,7 +14572,7 @@
                       <a:r>
                         <a:rPr lang="en-US" sz="1250" b="1" dirty="0">
                           <a:solidFill>
-                            <a:srgbClr val="2B2320"/>
+                            <a:schemeClr val="bg1"/>
                           </a:solidFill>
                           <a:latin typeface="Calibri" pitchFamily="34" charset="0"/>
                           <a:ea typeface="Calibri" pitchFamily="34" charset="-122"/>
@@ -14553,6 +14581,9 @@
                         <a:t>Chollo</a:t>
                       </a:r>
                       <a:endParaRPr lang="en-US" sz="1250" dirty="0">
+                        <a:solidFill>
+                          <a:schemeClr val="bg1"/>
+                        </a:solidFill>
                         <a:latin typeface="Calibri" charset="0"/>
                         <a:ea typeface="Calibri" charset="0"/>
                         <a:cs typeface="Calibri" charset="0"/>
@@ -14597,7 +14628,10 @@
                       <a:tailEnd type="none" w="med" len="med"/>
                     </a:lnB>
                     <a:solidFill>
-                      <a:srgbClr val="8FB7AE"/>
+                      <a:schemeClr val="accent6">
+                        <a:lumMod val="60000"/>
+                        <a:lumOff val="40000"/>
+                      </a:schemeClr>
                     </a:solidFill>
                   </a:tcPr>
                 </a:tc>
@@ -14612,7 +14646,7 @@
                       <a:r>
                         <a:rPr lang="en-US" sz="1250" dirty="0">
                           <a:solidFill>
-                            <a:srgbClr val="2B2320"/>
+                            <a:schemeClr val="bg1"/>
                           </a:solidFill>
                           <a:latin typeface="Calibri" pitchFamily="34" charset="0"/>
                           <a:ea typeface="Calibri" pitchFamily="34" charset="-122"/>
@@ -14621,6 +14655,9 @@
                         <a:t>0,85 ≤ r &lt; 0,97</a:t>
                       </a:r>
                       <a:endParaRPr lang="en-US" sz="1250" dirty="0">
+                        <a:solidFill>
+                          <a:schemeClr val="bg1"/>
+                        </a:solidFill>
                         <a:latin typeface="Calibri" charset="0"/>
                         <a:ea typeface="Calibri" charset="0"/>
                         <a:cs typeface="Calibri" charset="0"/>
@@ -14665,7 +14702,10 @@
                       <a:tailEnd type="none" w="med" len="med"/>
                     </a:lnB>
                     <a:solidFill>
-                      <a:srgbClr val="8FB7AE"/>
+                      <a:schemeClr val="accent6">
+                        <a:lumMod val="60000"/>
+                        <a:lumOff val="40000"/>
+                      </a:schemeClr>
                     </a:solidFill>
                   </a:tcPr>
                 </a:tc>
@@ -14680,7 +14720,7 @@
                       <a:r>
                         <a:rPr lang="en-US" sz="1100" dirty="0">
                           <a:solidFill>
-                            <a:srgbClr val="2B2320"/>
+                            <a:schemeClr val="bg1"/>
                           </a:solidFill>
                           <a:latin typeface="Calibri" pitchFamily="34" charset="0"/>
                           <a:ea typeface="Calibri" pitchFamily="34" charset="-122"/>
@@ -14689,6 +14729,9 @@
                         <a:t>Entre 3% y 15% por debajo</a:t>
                       </a:r>
                       <a:endParaRPr lang="en-US" sz="1100" dirty="0">
+                        <a:solidFill>
+                          <a:schemeClr val="bg1"/>
+                        </a:solidFill>
                         <a:latin typeface="Calibri" charset="0"/>
                         <a:ea typeface="Calibri" charset="0"/>
                         <a:cs typeface="Calibri" charset="0"/>
@@ -14733,7 +14776,10 @@
                       <a:tailEnd type="none" w="med" len="med"/>
                     </a:lnB>
                     <a:solidFill>
-                      <a:srgbClr val="8FB7AE"/>
+                      <a:schemeClr val="accent6">
+                        <a:lumMod val="60000"/>
+                        <a:lumOff val="40000"/>
+                      </a:schemeClr>
                     </a:solidFill>
                   </a:tcPr>
                 </a:tc>
@@ -14808,7 +14854,7 @@
                       <a:tailEnd type="none" w="med" len="med"/>
                     </a:lnB>
                     <a:solidFill>
-                      <a:srgbClr val="D8CFC5"/>
+                      <a:schemeClr val="accent4"/>
                     </a:solidFill>
                   </a:tcPr>
                 </a:tc>
@@ -14876,7 +14922,7 @@
                       <a:tailEnd type="none" w="med" len="med"/>
                     </a:lnB>
                     <a:solidFill>
-                      <a:srgbClr val="D8CFC5"/>
+                      <a:schemeClr val="accent4"/>
                     </a:solidFill>
                   </a:tcPr>
                 </a:tc>
@@ -14944,7 +14990,7 @@
                       <a:tailEnd type="none" w="med" len="med"/>
                     </a:lnB>
                     <a:solidFill>
-                      <a:srgbClr val="D8CFC5"/>
+                      <a:schemeClr val="accent4"/>
                     </a:solidFill>
                   </a:tcPr>
                 </a:tc>
@@ -15012,7 +15058,7 @@
                       <a:tailEnd type="none" w="med" len="med"/>
                     </a:lnB>
                     <a:solidFill>
-                      <a:srgbClr val="D8CFC5"/>
+                      <a:schemeClr val="accent4"/>
                     </a:solidFill>
                   </a:tcPr>
                 </a:tc>
@@ -15102,7 +15148,7 @@
                       <a:r>
                         <a:rPr lang="en-US" sz="1250" b="1" dirty="0">
                           <a:solidFill>
-                            <a:srgbClr val="FFFFFF"/>
+                            <a:schemeClr val="tx1"/>
                           </a:solidFill>
                           <a:latin typeface="Calibri" pitchFamily="34" charset="0"/>
                           <a:ea typeface="Calibri" pitchFamily="34" charset="-122"/>
@@ -15111,6 +15157,9 @@
                         <a:t>Inflado</a:t>
                       </a:r>
                       <a:endParaRPr lang="en-US" sz="1250" dirty="0">
+                        <a:solidFill>
+                          <a:schemeClr val="tx1"/>
+                        </a:solidFill>
                         <a:latin typeface="Calibri" charset="0"/>
                         <a:ea typeface="Calibri" charset="0"/>
                         <a:cs typeface="Calibri" charset="0"/>
@@ -15170,7 +15219,7 @@
                       <a:r>
                         <a:rPr lang="en-US" sz="1250" dirty="0">
                           <a:solidFill>
-                            <a:srgbClr val="FFFFFF"/>
+                            <a:schemeClr val="tx1"/>
                           </a:solidFill>
                           <a:latin typeface="Calibri" pitchFamily="34" charset="0"/>
                           <a:ea typeface="Calibri" pitchFamily="34" charset="-122"/>
@@ -15179,6 +15228,9 @@
                         <a:t>r &gt; 1,03</a:t>
                       </a:r>
                       <a:endParaRPr lang="en-US" sz="1250" dirty="0">
+                        <a:solidFill>
+                          <a:schemeClr val="tx1"/>
+                        </a:solidFill>
                         <a:latin typeface="Calibri" charset="0"/>
                         <a:ea typeface="Calibri" charset="0"/>
                         <a:cs typeface="Calibri" charset="0"/>
@@ -15238,7 +15290,7 @@
                       <a:r>
                         <a:rPr lang="en-US" sz="1100" dirty="0">
                           <a:solidFill>
-                            <a:srgbClr val="FFFFFF"/>
+                            <a:schemeClr val="tx1"/>
                           </a:solidFill>
                           <a:latin typeface="Calibri" pitchFamily="34" charset="0"/>
                           <a:ea typeface="Calibri" pitchFamily="34" charset="-122"/>
@@ -15247,6 +15299,9 @@
                         <a:t>Precio &gt; 3% por encima del justo</a:t>
                       </a:r>
                       <a:endParaRPr lang="en-US" sz="1100" dirty="0">
+                        <a:solidFill>
+                          <a:schemeClr val="tx1"/>
+                        </a:solidFill>
                         <a:latin typeface="Calibri" charset="0"/>
                         <a:ea typeface="Calibri" charset="0"/>
                         <a:cs typeface="Calibri" charset="0"/>
@@ -20572,7 +20627,7 @@
             <a:r>
               <a:rPr lang="en-US" sz="1550" b="1" dirty="0" err="1">
                 <a:solidFill>
-                  <a:srgbClr val="D99A3D"/>
+                  <a:srgbClr val="C00000"/>
                 </a:solidFill>
                 <a:latin typeface="Cambria" pitchFamily="34" charset="0"/>
                 <a:ea typeface="Cambria" pitchFamily="34" charset="-122"/>
@@ -20580,7 +20635,11 @@
               </a:rPr>
               <a:t>Problema</a:t>
             </a:r>
-            <a:endParaRPr lang="en-US" sz="1550" dirty="0"/>
+            <a:endParaRPr lang="en-US" sz="1550" dirty="0">
+              <a:solidFill>
+                <a:srgbClr val="C00000"/>
+              </a:solidFill>
+            </a:endParaRPr>
           </a:p>
         </p:txBody>
       </p:sp>
@@ -20605,11 +20664,12 @@
           <a:bodyPr wrap="square" lIns="0" tIns="0" rIns="0" bIns="0" rtlCol="0" anchor="t"/>
           <a:lstStyle/>
           <a:p>
-            <a:pPr marL="0" indent="0">
+            <a:pPr marL="285750" indent="-285750">
               <a:lnSpc>
                 <a:spcPct val="120000"/>
               </a:lnSpc>
-              <a:buNone/>
+              <a:buFont typeface="Arial" panose="020B0604020202020204" pitchFamily="34" charset="0"/>
+              <a:buChar char="•"/>
             </a:pPr>
             <a:r>
               <a:rPr lang="en-US" sz="1250" dirty="0">
@@ -20717,11 +20777,12 @@
             </a:r>
           </a:p>
           <a:p>
-            <a:pPr marL="0" indent="0">
+            <a:pPr marL="285750" indent="-285750">
               <a:lnSpc>
                 <a:spcPct val="120000"/>
               </a:lnSpc>
-              <a:buNone/>
+              <a:buFont typeface="Arial" panose="020B0604020202020204" pitchFamily="34" charset="0"/>
+              <a:buChar char="•"/>
             </a:pPr>
             <a:r>
               <a:rPr lang="en-US" sz="1250" dirty="0" err="1">
@@ -21071,7 +21132,9 @@
             <a:r>
               <a:rPr lang="en-US" sz="1550" b="1" dirty="0" err="1">
                 <a:solidFill>
-                  <a:srgbClr val="8C4029"/>
+                  <a:schemeClr val="accent6">
+                    <a:lumMod val="75000"/>
+                  </a:schemeClr>
                 </a:solidFill>
                 <a:latin typeface="Cambria" pitchFamily="34" charset="0"/>
                 <a:ea typeface="Cambria" pitchFamily="34" charset="-122"/>
@@ -21079,7 +21142,13 @@
               </a:rPr>
               <a:t>Solución</a:t>
             </a:r>
-            <a:endParaRPr lang="en-US" sz="1550" dirty="0"/>
+            <a:endParaRPr lang="en-US" sz="1550" dirty="0">
+              <a:solidFill>
+                <a:schemeClr val="accent6">
+                  <a:lumMod val="75000"/>
+                </a:schemeClr>
+              </a:solidFill>
+            </a:endParaRPr>
           </a:p>
         </p:txBody>
       </p:sp>
@@ -21123,9 +21192,6 @@
             </a:r>
             <a:r>
               <a:rPr lang="en-US" sz="1250" b="1" dirty="0">
-                <a:solidFill>
-                  <a:srgbClr val="8C4029"/>
-                </a:solidFill>
                 <a:latin typeface="Calibri" pitchFamily="34" charset="0"/>
                 <a:ea typeface="Calibri" pitchFamily="34" charset="-122"/>
                 <a:cs typeface="Calibri" pitchFamily="34" charset="-120"/>
@@ -21143,32 +21209,148 @@
               </a:rPr>
               <a:t>. Se conservan 20 de los 100 árboles: </a:t>
             </a:r>
+          </a:p>
+          <a:p>
+            <a:pPr marL="285750" indent="-285750">
+              <a:lnSpc>
+                <a:spcPct val="120000"/>
+              </a:lnSpc>
+              <a:buFont typeface="Arial" panose="020B0604020202020204" pitchFamily="34" charset="0"/>
+              <a:buChar char="•"/>
+            </a:pPr>
             <a:r>
               <a:rPr lang="en-US" sz="1250" b="1" dirty="0">
                 <a:solidFill>
-                  <a:srgbClr val="8C4029"/>
-                </a:solidFill>
-                <a:latin typeface="Calibri" pitchFamily="34" charset="0"/>
-                <a:ea typeface="Calibri" pitchFamily="34" charset="-122"/>
-                <a:cs typeface="Calibri" pitchFamily="34" charset="-120"/>
-              </a:rPr>
-              <a:t>~373MB en RAM</a:t>
+                  <a:schemeClr val="accent6">
+                    <a:lumMod val="75000"/>
+                  </a:schemeClr>
+                </a:solidFill>
+                <a:latin typeface="Calibri" pitchFamily="34" charset="0"/>
+                <a:ea typeface="Calibri" pitchFamily="34" charset="-122"/>
+                <a:cs typeface="Calibri" pitchFamily="34" charset="-120"/>
+              </a:rPr>
+              <a:t>~373MB </a:t>
+            </a:r>
+            <a:r>
+              <a:rPr lang="en-US" sz="1250" b="1" dirty="0" err="1">
+                <a:solidFill>
+                  <a:schemeClr val="accent6">
+                    <a:lumMod val="75000"/>
+                  </a:schemeClr>
+                </a:solidFill>
+                <a:latin typeface="Calibri" pitchFamily="34" charset="0"/>
+                <a:ea typeface="Calibri" pitchFamily="34" charset="-122"/>
+                <a:cs typeface="Calibri" pitchFamily="34" charset="-120"/>
+              </a:rPr>
+              <a:t>en</a:t>
+            </a:r>
+            <a:r>
+              <a:rPr lang="en-US" sz="1250" b="1" dirty="0">
+                <a:solidFill>
+                  <a:schemeClr val="accent6">
+                    <a:lumMod val="75000"/>
+                  </a:schemeClr>
+                </a:solidFill>
+                <a:latin typeface="Calibri" pitchFamily="34" charset="0"/>
+                <a:ea typeface="Calibri" pitchFamily="34" charset="-122"/>
+                <a:cs typeface="Calibri" pitchFamily="34" charset="-120"/>
+              </a:rPr>
+              <a:t> RAM</a:t>
             </a:r>
             <a:r>
               <a:rPr lang="en-US" sz="1250" dirty="0">
                 <a:solidFill>
+                  <a:schemeClr val="accent6">
+                    <a:lumMod val="75000"/>
+                  </a:schemeClr>
+                </a:solidFill>
+                <a:latin typeface="Calibri" pitchFamily="34" charset="0"/>
+                <a:ea typeface="Calibri" pitchFamily="34" charset="-122"/>
+                <a:cs typeface="Calibri" pitchFamily="34" charset="-120"/>
+              </a:rPr>
+              <a:t> </a:t>
+            </a:r>
+            <a:r>
+              <a:rPr lang="en-US" sz="1250" dirty="0">
+                <a:solidFill>
                   <a:srgbClr val="2B2320"/>
                 </a:solidFill>
                 <a:latin typeface="Calibri" pitchFamily="34" charset="0"/>
                 <a:ea typeface="Calibri" pitchFamily="34" charset="-122"/>
                 <a:cs typeface="Calibri" pitchFamily="34" charset="-120"/>
               </a:rPr>
-              <a:t> y </a:t>
+              <a:t>(&lt;1GB del </a:t>
+            </a:r>
+            <a:r>
+              <a:rPr lang="en-US" sz="1250" dirty="0" err="1">
+                <a:solidFill>
+                  <a:srgbClr val="2B2320"/>
+                </a:solidFill>
+                <a:latin typeface="Calibri" pitchFamily="34" charset="0"/>
+                <a:ea typeface="Calibri" pitchFamily="34" charset="-122"/>
+                <a:cs typeface="Calibri" pitchFamily="34" charset="-120"/>
+              </a:rPr>
+              <a:t>límite</a:t>
+            </a:r>
+            <a:r>
+              <a:rPr lang="en-US" sz="1250" dirty="0">
+                <a:solidFill>
+                  <a:srgbClr val="2B2320"/>
+                </a:solidFill>
+                <a:latin typeface="Calibri" pitchFamily="34" charset="0"/>
+                <a:ea typeface="Calibri" pitchFamily="34" charset="-122"/>
+                <a:cs typeface="Calibri" pitchFamily="34" charset="-120"/>
+              </a:rPr>
+              <a:t> de </a:t>
+            </a:r>
+            <a:r>
+              <a:rPr lang="en-US" sz="1250" dirty="0" err="1">
+                <a:solidFill>
+                  <a:srgbClr val="2B2320"/>
+                </a:solidFill>
+                <a:latin typeface="Calibri" pitchFamily="34" charset="0"/>
+                <a:ea typeface="Calibri" pitchFamily="34" charset="-122"/>
+                <a:cs typeface="Calibri" pitchFamily="34" charset="-120"/>
+              </a:rPr>
+              <a:t>Streamlit</a:t>
+            </a:r>
+            <a:r>
+              <a:rPr lang="en-US" sz="1250" dirty="0">
+                <a:solidFill>
+                  <a:srgbClr val="2B2320"/>
+                </a:solidFill>
+                <a:latin typeface="Calibri" pitchFamily="34" charset="0"/>
+                <a:ea typeface="Calibri" pitchFamily="34" charset="-122"/>
+                <a:cs typeface="Calibri" pitchFamily="34" charset="-120"/>
+              </a:rPr>
+              <a:t> Cloud)</a:t>
+            </a:r>
+          </a:p>
+          <a:p>
+            <a:pPr marL="285750" indent="-285750">
+              <a:lnSpc>
+                <a:spcPct val="120000"/>
+              </a:lnSpc>
+              <a:buFont typeface="Arial" panose="020B0604020202020204" pitchFamily="34" charset="0"/>
+              <a:buChar char="•"/>
+            </a:pPr>
+            <a:r>
+              <a:rPr lang="en-US" sz="1250" dirty="0">
+                <a:solidFill>
+                  <a:srgbClr val="2B2320"/>
+                </a:solidFill>
+                <a:latin typeface="Calibri" pitchFamily="34" charset="0"/>
+                <a:ea typeface="Calibri" pitchFamily="34" charset="-122"/>
+                <a:cs typeface="Calibri" pitchFamily="34" charset="-120"/>
+              </a:rPr>
+              <a:t> </a:t>
             </a:r>
             <a:r>
               <a:rPr lang="en-US" sz="1250" b="1" dirty="0">
                 <a:solidFill>
-                  <a:srgbClr val="8C4029"/>
+                  <a:schemeClr val="accent6">
+                    <a:lumMod val="75000"/>
+                  </a:schemeClr>
                 </a:solidFill>
                 <a:latin typeface="Calibri" pitchFamily="34" charset="0"/>
                 <a:ea typeface="Calibri" pitchFamily="34" charset="-122"/>
@@ -21179,13 +21361,26 @@
             <a:r>
               <a:rPr lang="en-US" sz="1250" dirty="0">
                 <a:solidFill>
+                  <a:schemeClr val="accent6">
+                    <a:lumMod val="75000"/>
+                  </a:schemeClr>
+                </a:solidFill>
+                <a:latin typeface="Calibri" pitchFamily="34" charset="0"/>
+                <a:ea typeface="Calibri" pitchFamily="34" charset="-122"/>
+                <a:cs typeface="Calibri" pitchFamily="34" charset="-120"/>
+              </a:rPr>
+              <a:t> </a:t>
+            </a:r>
+            <a:r>
+              <a:rPr lang="en-US" sz="1250" dirty="0">
+                <a:solidFill>
                   <a:srgbClr val="2B2320"/>
                 </a:solidFill>
                 <a:latin typeface="Calibri" pitchFamily="34" charset="0"/>
                 <a:ea typeface="Calibri" pitchFamily="34" charset="-122"/>
                 <a:cs typeface="Calibri" pitchFamily="34" charset="-120"/>
               </a:rPr>
-              <a:t> en disco (&lt; 100MB del </a:t>
+              <a:t>en disco (&lt; 100MB del </a:t>
             </a:r>
             <a:r>
               <a:rPr lang="en-US" sz="1250" dirty="0" err="1">
@@ -21222,7 +21417,7 @@
           <p:nvPr>
             <p:extLst>
               <p:ext uri="{D42A27DB-BD31-4B8C-83A1-F6EECF244321}">
-                <p14:modId xmlns:p14="http://schemas.microsoft.com/office/powerpoint/2010/main" val="1579011935"/>
+                <p14:modId xmlns:p14="http://schemas.microsoft.com/office/powerpoint/2010/main" val="103355414"/>
               </p:ext>
             </p:extLst>
           </p:nvPr>
@@ -21963,7 +22158,9 @@
                       <a:r>
                         <a:rPr lang="en-US" sz="1250" b="1" dirty="0">
                           <a:solidFill>
-                            <a:srgbClr val="8C4029"/>
+                            <a:schemeClr val="accent6">
+                              <a:lumMod val="75000"/>
+                            </a:schemeClr>
                           </a:solidFill>
                           <a:latin typeface="Calibri" pitchFamily="34" charset="0"/>
                           <a:ea typeface="Calibri" pitchFamily="34" charset="-122"/>
@@ -21972,6 +22169,11 @@
                         <a:t>Podado (producción)</a:t>
                       </a:r>
                       <a:endParaRPr lang="en-US" sz="1250" dirty="0">
+                        <a:solidFill>
+                          <a:schemeClr val="accent6">
+                            <a:lumMod val="75000"/>
+                          </a:schemeClr>
+                        </a:solidFill>
                         <a:latin typeface="Calibri" charset="0"/>
                         <a:ea typeface="Calibri" charset="0"/>
                         <a:cs typeface="Calibri" charset="0"/>
@@ -22028,7 +22230,9 @@
                       <a:r>
                         <a:rPr lang="en-US" sz="1250" b="1" dirty="0">
                           <a:solidFill>
-                            <a:srgbClr val="8C4029"/>
+                            <a:schemeClr val="accent6">
+                              <a:lumMod val="75000"/>
+                            </a:schemeClr>
                           </a:solidFill>
                           <a:latin typeface="Calibri" pitchFamily="34" charset="0"/>
                           <a:ea typeface="Calibri" pitchFamily="34" charset="-122"/>
@@ -22037,6 +22241,11 @@
                         <a:t>20</a:t>
                       </a:r>
                       <a:endParaRPr lang="en-US" sz="1250" dirty="0">
+                        <a:solidFill>
+                          <a:schemeClr val="accent6">
+                            <a:lumMod val="75000"/>
+                          </a:schemeClr>
+                        </a:solidFill>
                         <a:latin typeface="Calibri" charset="0"/>
                         <a:ea typeface="Calibri" charset="0"/>
                         <a:cs typeface="Calibri" charset="0"/>
@@ -22093,7 +22302,9 @@
                       <a:r>
                         <a:rPr lang="en-US" sz="1250" b="1" dirty="0">
                           <a:solidFill>
-                            <a:srgbClr val="8C4029"/>
+                            <a:schemeClr val="accent6">
+                              <a:lumMod val="75000"/>
+                            </a:schemeClr>
                           </a:solidFill>
                           <a:latin typeface="Calibri" pitchFamily="34" charset="0"/>
                           <a:ea typeface="Calibri" pitchFamily="34" charset="-122"/>
@@ -22102,6 +22313,11 @@
                         <a:t>0,8634</a:t>
                       </a:r>
                       <a:endParaRPr lang="en-US" sz="1250" dirty="0">
+                        <a:solidFill>
+                          <a:schemeClr val="accent6">
+                            <a:lumMod val="75000"/>
+                          </a:schemeClr>
+                        </a:solidFill>
                         <a:latin typeface="Calibri" charset="0"/>
                         <a:ea typeface="Calibri" charset="0"/>
                         <a:cs typeface="Calibri" charset="0"/>
@@ -22158,7 +22374,9 @@
                       <a:r>
                         <a:rPr lang="en-US" sz="1250" b="1" dirty="0">
                           <a:solidFill>
-                            <a:srgbClr val="8C4029"/>
+                            <a:schemeClr val="accent6">
+                              <a:lumMod val="75000"/>
+                            </a:schemeClr>
                           </a:solidFill>
                           <a:latin typeface="Calibri" pitchFamily="34" charset="0"/>
                           <a:ea typeface="Calibri" pitchFamily="34" charset="-122"/>
@@ -22167,6 +22385,11 @@
                         <a:t>19,79</a:t>
                       </a:r>
                       <a:endParaRPr lang="en-US" sz="1250" dirty="0">
+                        <a:solidFill>
+                          <a:schemeClr val="accent6">
+                            <a:lumMod val="75000"/>
+                          </a:schemeClr>
+                        </a:solidFill>
                         <a:latin typeface="Calibri" charset="0"/>
                         <a:ea typeface="Calibri" charset="0"/>
                         <a:cs typeface="Calibri" charset="0"/>
@@ -22223,7 +22446,9 @@
                       <a:r>
                         <a:rPr lang="en-US" sz="1250" b="1" dirty="0">
                           <a:solidFill>
-                            <a:srgbClr val="8C4029"/>
+                            <a:schemeClr val="accent6">
+                              <a:lumMod val="75000"/>
+                            </a:schemeClr>
                           </a:solidFill>
                           <a:latin typeface="Calibri" pitchFamily="34" charset="0"/>
                           <a:ea typeface="Calibri" pitchFamily="34" charset="-122"/>
@@ -22232,6 +22457,11 @@
                         <a:t>33,57</a:t>
                       </a:r>
                       <a:endParaRPr lang="en-US" sz="1250" dirty="0">
+                        <a:solidFill>
+                          <a:schemeClr val="accent6">
+                            <a:lumMod val="75000"/>
+                          </a:schemeClr>
+                        </a:solidFill>
                         <a:latin typeface="Calibri" charset="0"/>
                         <a:ea typeface="Calibri" charset="0"/>
                         <a:cs typeface="Calibri" charset="0"/>
@@ -22373,14 +22603,47 @@
           <a:p>
             <a:pPr algn="ctr"/>
             <a:r>
-              <a:rPr sz="1250" b="1">
+              <a:rPr sz="1250" b="1" dirty="0">
                 <a:solidFill>
                   <a:srgbClr val="241A16"/>
                 </a:solidFill>
                 <a:latin typeface="Calibri"/>
               </a:rPr>
-              <a:t>373MB en RAM (1/4 del original) → ya cabe en el límite gratuito de Streamlit Cloud (~1GB)</a:t>
-            </a:r>
+              <a:t>373MB </a:t>
+            </a:r>
+            <a:r>
+              <a:rPr sz="1250" b="1" dirty="0" err="1">
+                <a:solidFill>
+                  <a:srgbClr val="241A16"/>
+                </a:solidFill>
+                <a:latin typeface="Calibri"/>
+              </a:rPr>
+              <a:t>en</a:t>
+            </a:r>
+            <a:r>
+              <a:rPr sz="1250" b="1" dirty="0">
+                <a:solidFill>
+                  <a:srgbClr val="241A16"/>
+                </a:solidFill>
+                <a:latin typeface="Calibri"/>
+              </a:rPr>
+              <a:t> RAM (1/4 del original)</a:t>
+            </a:r>
+            <a:r>
+              <a:rPr lang="es-ES" sz="1250" b="1" dirty="0">
+                <a:solidFill>
+                  <a:srgbClr val="241A16"/>
+                </a:solidFill>
+                <a:latin typeface="Calibri"/>
+              </a:rPr>
+              <a:t> y 59MB en disco</a:t>
+            </a:r>
+            <a:endParaRPr sz="1250" b="1" dirty="0">
+              <a:solidFill>
+                <a:srgbClr val="241A16"/>
+              </a:solidFill>
+              <a:latin typeface="Calibri"/>
+            </a:endParaRPr>
           </a:p>
         </p:txBody>
       </p:sp>

</xml_diff>

<commit_message>
clean: Más grande el corrplot, eliminamos "nunca antes usado) en slice 15, eliminamos en slice 21 "(producción)" y retocamos colores, y estilizamos despedida a color claro
</commit_message>
<xml_diff>
--- a/TFG_Chollos/Presentacion_Defensa_TFG.pptx
+++ b/TFG_Chollos/Presentacion_Defensa_TFG.pptx
@@ -9772,8 +9772,8 @@
         </p:blipFill>
         <p:spPr>
           <a:xfrm>
-            <a:off x="177265" y="1136719"/>
-            <a:ext cx="6654856" cy="5349655"/>
+            <a:off x="-1" y="1136719"/>
+            <a:ext cx="7496355" cy="5349655"/>
           </a:xfrm>
           <a:prstGeom prst="rect">
             <a:avLst/>
@@ -13174,7 +13174,23 @@
                 <a:ea typeface="Calibri" pitchFamily="34" charset="-122"/>
                 <a:cs typeface="Calibri" pitchFamily="34" charset="-120"/>
               </a:rPr>
-              <a:t>Sobre el conjunto de prueba (nunca usado en el entrenamiento): </a:t>
+              <a:t>Sobre el conjunto de </a:t>
+            </a:r>
+            <a:r>
+              <a:rPr lang="en-US" sz="1300" dirty="0" err="1">
+                <a:latin typeface="Calibri" pitchFamily="34" charset="0"/>
+                <a:ea typeface="Calibri" pitchFamily="34" charset="-122"/>
+                <a:cs typeface="Calibri" pitchFamily="34" charset="-120"/>
+              </a:rPr>
+              <a:t>prueba</a:t>
+            </a:r>
+            <a:r>
+              <a:rPr lang="en-US" sz="1300" dirty="0">
+                <a:latin typeface="Calibri" pitchFamily="34" charset="0"/>
+                <a:ea typeface="Calibri" pitchFamily="34" charset="-122"/>
+                <a:cs typeface="Calibri" pitchFamily="34" charset="-120"/>
+              </a:rPr>
+              <a:t>:</a:t>
             </a:r>
             <a:endParaRPr lang="en-US" sz="1300" dirty="0"/>
           </a:p>
@@ -14085,7 +14101,51 @@
                 <a:ea typeface="Calibri" pitchFamily="34" charset="-122"/>
                 <a:cs typeface="Calibri" pitchFamily="34" charset="-120"/>
               </a:rPr>
-              <a:t>     r &lt; 1 → potencial chollo          r &gt; 1 → alojamiento inflado</a:t>
+              <a:t>     r &lt; 1 → potencial chollo          r &gt; 1 → </a:t>
+            </a:r>
+            <a:r>
+              <a:rPr lang="en-US" sz="1300" dirty="0" err="1">
+                <a:solidFill>
+                  <a:srgbClr val="2B2320"/>
+                </a:solidFill>
+                <a:latin typeface="Calibri" pitchFamily="34" charset="0"/>
+                <a:ea typeface="Calibri" pitchFamily="34" charset="-122"/>
+                <a:cs typeface="Calibri" pitchFamily="34" charset="-120"/>
+              </a:rPr>
+              <a:t>alojamiento</a:t>
+            </a:r>
+            <a:r>
+              <a:rPr lang="en-US" sz="1300" dirty="0">
+                <a:solidFill>
+                  <a:srgbClr val="2B2320"/>
+                </a:solidFill>
+                <a:latin typeface="Calibri" pitchFamily="34" charset="0"/>
+                <a:ea typeface="Calibri" pitchFamily="34" charset="-122"/>
+                <a:cs typeface="Calibri" pitchFamily="34" charset="-120"/>
+              </a:rPr>
+              <a:t> con </a:t>
+            </a:r>
+            <a:r>
+              <a:rPr lang="en-US" sz="1300" dirty="0" err="1">
+                <a:solidFill>
+                  <a:srgbClr val="2B2320"/>
+                </a:solidFill>
+                <a:latin typeface="Calibri" pitchFamily="34" charset="0"/>
+                <a:ea typeface="Calibri" pitchFamily="34" charset="-122"/>
+                <a:cs typeface="Calibri" pitchFamily="34" charset="-120"/>
+              </a:rPr>
+              <a:t>precio</a:t>
+            </a:r>
+            <a:r>
+              <a:rPr lang="en-US" sz="1300" dirty="0">
+                <a:solidFill>
+                  <a:srgbClr val="2B2320"/>
+                </a:solidFill>
+                <a:latin typeface="Calibri" pitchFamily="34" charset="0"/>
+                <a:ea typeface="Calibri" pitchFamily="34" charset="-122"/>
+                <a:cs typeface="Calibri" pitchFamily="34" charset="-120"/>
+              </a:rPr>
+              <a:t> inflado</a:t>
             </a:r>
             <a:endParaRPr lang="en-US" sz="1600" dirty="0"/>
           </a:p>
@@ -21398,6 +21458,9 @@
             </a:r>
             <a:r>
               <a:rPr lang="en-US" sz="1250" b="1" dirty="0">
+                <a:solidFill>
+                  <a:srgbClr val="C00000"/>
+                </a:solidFill>
                 <a:latin typeface="Calibri" pitchFamily="34" charset="0"/>
                 <a:ea typeface="Calibri" pitchFamily="34" charset="-122"/>
                 <a:cs typeface="Calibri" pitchFamily="34" charset="-120"/>
@@ -21406,6 +21469,9 @@
             </a:r>
             <a:r>
               <a:rPr lang="en-US" sz="1250" b="1" dirty="0" err="1">
+                <a:solidFill>
+                  <a:srgbClr val="C00000"/>
+                </a:solidFill>
                 <a:latin typeface="Calibri" pitchFamily="34" charset="0"/>
                 <a:ea typeface="Calibri" pitchFamily="34" charset="-122"/>
                 <a:cs typeface="Calibri" pitchFamily="34" charset="-120"/>
@@ -21414,6 +21480,9 @@
             </a:r>
             <a:r>
               <a:rPr lang="en-US" sz="1250" b="1" dirty="0">
+                <a:solidFill>
+                  <a:srgbClr val="C00000"/>
+                </a:solidFill>
                 <a:latin typeface="Calibri" pitchFamily="34" charset="0"/>
                 <a:ea typeface="Calibri" pitchFamily="34" charset="-122"/>
                 <a:cs typeface="Calibri" pitchFamily="34" charset="-120"/>
@@ -21422,11 +21491,22 @@
             </a:r>
             <a:r>
               <a:rPr lang="en-US" sz="1250" dirty="0">
-                <a:latin typeface="Calibri" pitchFamily="34" charset="0"/>
-                <a:ea typeface="Calibri" pitchFamily="34" charset="-122"/>
-                <a:cs typeface="Calibri" pitchFamily="34" charset="-120"/>
-              </a:rPr>
-              <a:t> al </a:t>
+                <a:solidFill>
+                  <a:srgbClr val="C00000"/>
+                </a:solidFill>
+                <a:latin typeface="Calibri" pitchFamily="34" charset="0"/>
+                <a:ea typeface="Calibri" pitchFamily="34" charset="-122"/>
+                <a:cs typeface="Calibri" pitchFamily="34" charset="-120"/>
+              </a:rPr>
+              <a:t> </a:t>
+            </a:r>
+            <a:r>
+              <a:rPr lang="en-US" sz="1250" dirty="0">
+                <a:latin typeface="Calibri" pitchFamily="34" charset="0"/>
+                <a:ea typeface="Calibri" pitchFamily="34" charset="-122"/>
+                <a:cs typeface="Calibri" pitchFamily="34" charset="-120"/>
+              </a:rPr>
+              <a:t>al </a:t>
             </a:r>
             <a:r>
               <a:rPr lang="en-US" sz="1250" dirty="0" err="1">
@@ -21519,6 +21599,9 @@
             </a:r>
             <a:r>
               <a:rPr lang="en-US" sz="1250" b="1" dirty="0">
+                <a:solidFill>
+                  <a:srgbClr val="C00000"/>
+                </a:solidFill>
                 <a:latin typeface="Calibri" pitchFamily="34" charset="0"/>
                 <a:ea typeface="Calibri" pitchFamily="34" charset="-122"/>
                 <a:cs typeface="Calibri" pitchFamily="34" charset="-120"/>
@@ -21527,6 +21610,9 @@
             </a:r>
             <a:r>
               <a:rPr lang="en-US" sz="1250" b="1" dirty="0" err="1">
+                <a:solidFill>
+                  <a:srgbClr val="C00000"/>
+                </a:solidFill>
                 <a:latin typeface="Calibri" pitchFamily="34" charset="0"/>
                 <a:ea typeface="Calibri" pitchFamily="34" charset="-122"/>
                 <a:cs typeface="Calibri" pitchFamily="34" charset="-120"/>
@@ -21535,6 +21621,9 @@
             </a:r>
             <a:r>
               <a:rPr lang="en-US" sz="1250" b="1" dirty="0">
+                <a:solidFill>
+                  <a:srgbClr val="C00000"/>
+                </a:solidFill>
                 <a:latin typeface="Calibri" pitchFamily="34" charset="0"/>
                 <a:ea typeface="Calibri" pitchFamily="34" charset="-122"/>
                 <a:cs typeface="Calibri" pitchFamily="34" charset="-120"/>
@@ -22043,17 +22132,6 @@
               <a:buChar char="•"/>
             </a:pPr>
             <a:r>
-              <a:rPr lang="en-US" sz="1250" dirty="0">
-                <a:solidFill>
-                  <a:srgbClr val="2B2320"/>
-                </a:solidFill>
-                <a:latin typeface="Calibri" pitchFamily="34" charset="0"/>
-                <a:ea typeface="Calibri" pitchFamily="34" charset="-122"/>
-                <a:cs typeface="Calibri" pitchFamily="34" charset="-120"/>
-              </a:rPr>
-              <a:t> </a:t>
-            </a:r>
-            <a:r>
               <a:rPr lang="en-US" sz="1250" b="1" dirty="0">
                 <a:solidFill>
                   <a:schemeClr val="accent6">
@@ -22064,10 +22142,10 @@
                 <a:ea typeface="Calibri" pitchFamily="34" charset="-122"/>
                 <a:cs typeface="Calibri" pitchFamily="34" charset="-120"/>
               </a:rPr>
-              <a:t>~59MB comprimido</a:t>
-            </a:r>
-            <a:r>
-              <a:rPr lang="en-US" sz="1250" dirty="0">
+              <a:t>~59MB </a:t>
+            </a:r>
+            <a:r>
+              <a:rPr lang="en-US" sz="1250" b="1" dirty="0" err="1">
                 <a:solidFill>
                   <a:schemeClr val="accent6">
                     <a:lumMod val="75000"/>
@@ -22077,9 +22155,33 @@
                 <a:ea typeface="Calibri" pitchFamily="34" charset="-122"/>
                 <a:cs typeface="Calibri" pitchFamily="34" charset="-120"/>
               </a:rPr>
+              <a:t>comprimido</a:t>
+            </a:r>
+            <a:r>
+              <a:rPr lang="en-US" sz="1250" dirty="0">
+                <a:solidFill>
+                  <a:schemeClr val="accent6">
+                    <a:lumMod val="75000"/>
+                  </a:schemeClr>
+                </a:solidFill>
+                <a:latin typeface="Calibri" pitchFamily="34" charset="0"/>
+                <a:ea typeface="Calibri" pitchFamily="34" charset="-122"/>
+                <a:cs typeface="Calibri" pitchFamily="34" charset="-120"/>
+              </a:rPr>
               <a:t> </a:t>
             </a:r>
             <a:r>
+              <a:rPr lang="en-US" sz="1250" dirty="0" err="1">
+                <a:solidFill>
+                  <a:srgbClr val="2B2320"/>
+                </a:solidFill>
+                <a:latin typeface="Calibri" pitchFamily="34" charset="0"/>
+                <a:ea typeface="Calibri" pitchFamily="34" charset="-122"/>
+                <a:cs typeface="Calibri" pitchFamily="34" charset="-120"/>
+              </a:rPr>
+              <a:t>en</a:t>
+            </a:r>
+            <a:r>
               <a:rPr lang="en-US" sz="1250" dirty="0">
                 <a:solidFill>
                   <a:srgbClr val="2B2320"/>
@@ -22088,7 +22190,7 @@
                 <a:ea typeface="Calibri" pitchFamily="34" charset="-122"/>
                 <a:cs typeface="Calibri" pitchFamily="34" charset="-120"/>
               </a:rPr>
-              <a:t>en disco (&lt; 100MB del </a:t>
+              <a:t> disco (&lt; 100MB del </a:t>
             </a:r>
             <a:r>
               <a:rPr lang="en-US" sz="1250" dirty="0" err="1">
@@ -22112,7 +22214,6 @@
               </a:rPr>
               <a:t> de GitHub).</a:t>
             </a:r>
-            <a:endParaRPr lang="en-US" sz="1250" dirty="0"/>
           </a:p>
         </p:txBody>
       </p:sp>
@@ -22125,7 +22226,7 @@
           <p:nvPr>
             <p:extLst>
               <p:ext uri="{D42A27DB-BD31-4B8C-83A1-F6EECF244321}">
-                <p14:modId xmlns:p14="http://schemas.microsoft.com/office/powerpoint/2010/main" val="1625249065"/>
+                <p14:modId xmlns:p14="http://schemas.microsoft.com/office/powerpoint/2010/main" val="1315385388"/>
               </p:ext>
             </p:extLst>
           </p:nvPr>
@@ -22864,7 +22965,7 @@
                         <a:buNone/>
                       </a:pPr>
                       <a:r>
-                        <a:rPr lang="en-US" sz="1250" b="1" dirty="0">
+                        <a:rPr lang="en-US" sz="1250" b="1" dirty="0" err="1">
                           <a:solidFill>
                             <a:schemeClr val="accent6">
                               <a:lumMod val="75000"/>
@@ -22874,7 +22975,7 @@
                           <a:ea typeface="Calibri" pitchFamily="34" charset="-122"/>
                           <a:cs typeface="Calibri" pitchFamily="34" charset="-120"/>
                         </a:rPr>
-                        <a:t>Podado (producción)</a:t>
+                        <a:t>Podado</a:t>
                       </a:r>
                       <a:endParaRPr lang="en-US" sz="1250" dirty="0">
                         <a:solidFill>
@@ -25214,7 +25315,7 @@
     <p:bg>
       <p:bgPr>
         <a:solidFill>
-          <a:srgbClr val="241A16"/>
+          <a:schemeClr val="bg1"/>
         </a:solidFill>
         <a:effectLst/>
       </p:bgPr>
@@ -25259,9 +25360,6 @@
             </a:pPr>
             <a:r>
               <a:rPr lang="en-US" sz="4600" b="1" dirty="0">
-                <a:solidFill>
-                  <a:srgbClr val="FFFFFF"/>
-                </a:solidFill>
                 <a:latin typeface="Cambria" pitchFamily="34" charset="0"/>
                 <a:ea typeface="Cambria" pitchFamily="34" charset="-122"/>
                 <a:cs typeface="Cambria" pitchFamily="34" charset="-120"/>
@@ -25298,9 +25396,6 @@
             </a:pPr>
             <a:r>
               <a:rPr lang="en-US" sz="1500" i="1" dirty="0">
-                <a:solidFill>
-                  <a:srgbClr val="D8CCC3"/>
-                </a:solidFill>
                 <a:latin typeface="Calibri" pitchFamily="34" charset="0"/>
                 <a:ea typeface="Calibri" pitchFamily="34" charset="-122"/>
                 <a:cs typeface="Calibri" pitchFamily="34" charset="-120"/>
@@ -25328,7 +25423,7 @@
             </a:avLst>
           </a:prstGeom>
           <a:solidFill>
-            <a:srgbClr val="342722"/>
+            <a:schemeClr val="bg2"/>
           </a:solidFill>
           <a:ln/>
         </p:spPr>
@@ -25417,9 +25512,6 @@
             </a:pPr>
             <a:r>
               <a:rPr lang="en-US" sz="1300" b="1" dirty="0">
-                <a:solidFill>
-                  <a:srgbClr val="C7B9AF"/>
-                </a:solidFill>
                 <a:latin typeface="Calibri" pitchFamily="34" charset="0"/>
                 <a:ea typeface="Calibri" pitchFamily="34" charset="-122"/>
                 <a:cs typeface="Calibri" pitchFamily="34" charset="-120"/>
@@ -25458,9 +25550,6 @@
             </a:pPr>
             <a:r>
               <a:rPr lang="en-US" sz="1300" u="sng" dirty="0">
-                <a:solidFill>
-                  <a:srgbClr val="FFFFFF"/>
-                </a:solidFill>
                 <a:latin typeface="Calibri" pitchFamily="34" charset="0"/>
                 <a:ea typeface="Calibri" pitchFamily="34" charset="-122"/>
                 <a:cs typeface="Calibri" pitchFamily="34" charset="-120"/>
@@ -25495,7 +25584,7 @@
             </a:avLst>
           </a:prstGeom>
           <a:solidFill>
-            <a:srgbClr val="342722"/>
+            <a:schemeClr val="bg2"/>
           </a:solidFill>
           <a:ln/>
         </p:spPr>
@@ -25584,9 +25673,6 @@
             </a:pPr>
             <a:r>
               <a:rPr lang="en-US" sz="1300" b="1" dirty="0">
-                <a:solidFill>
-                  <a:srgbClr val="C7B9AF"/>
-                </a:solidFill>
                 <a:latin typeface="Calibri" pitchFamily="34" charset="0"/>
                 <a:ea typeface="Calibri" pitchFamily="34" charset="-122"/>
                 <a:cs typeface="Calibri" pitchFamily="34" charset="-120"/>
@@ -25625,9 +25711,6 @@
             </a:pPr>
             <a:r>
               <a:rPr lang="en-US" sz="1300" u="sng" dirty="0">
-                <a:solidFill>
-                  <a:srgbClr val="FFFFFF"/>
-                </a:solidFill>
                 <a:latin typeface="Calibri" pitchFamily="34" charset="0"/>
                 <a:ea typeface="Calibri" pitchFamily="34" charset="-122"/>
                 <a:cs typeface="Calibri" pitchFamily="34" charset="-120"/>
@@ -34383,42 +34466,49 @@
           </a:p>
         </p:txBody>
       </p:sp>
-      <p:pic>
-        <p:nvPicPr>
-          <p:cNvPr id="20" name="Gráfico 19" descr="Flechas de cheurón con relleno sólido">
+      <p:sp>
+        <p:nvSpPr>
+          <p:cNvPr id="21" name="CuadroTexto 20">
             <a:extLst>
               <a:ext uri="{FF2B5EF4-FFF2-40B4-BE49-F238E27FC236}">
-                <a16:creationId xmlns:a16="http://schemas.microsoft.com/office/drawing/2014/main" id="{67C9516D-B195-8BDC-2581-2DC136E05BBB}"/>
+                <a16:creationId xmlns:a16="http://schemas.microsoft.com/office/drawing/2014/main" id="{C256E2FD-D61C-572F-AA4B-BA8AE6304A10}"/>
               </a:ext>
             </a:extLst>
           </p:cNvPr>
-          <p:cNvPicPr>
-            <a:picLocks noChangeAspect="1"/>
-          </p:cNvPicPr>
-          <p:nvPr/>
-        </p:nvPicPr>
-        <p:blipFill>
-          <a:blip r:embed="rId8">
-            <a:extLst>
-              <a:ext uri="{96DAC541-7B7A-43D3-8B79-37D633B846F1}">
-                <asvg:svgBlip xmlns:asvg="http://schemas.microsoft.com/office/drawing/2016/SVG/main" r:embed="rId9"/>
-              </a:ext>
-            </a:extLst>
-          </a:blip>
-          <a:stretch>
-            <a:fillRect/>
-          </a:stretch>
-        </p:blipFill>
-        <p:spPr>
-          <a:xfrm>
-            <a:off x="8278697" y="4919513"/>
-            <a:ext cx="335280" cy="335280"/>
+          <p:cNvSpPr txBox="1"/>
+          <p:nvPr/>
+        </p:nvSpPr>
+        <p:spPr>
+          <a:xfrm>
+            <a:off x="8227466" y="4856320"/>
+            <a:ext cx="437741" cy="461665"/>
           </a:xfrm>
           <a:prstGeom prst="rect">
             <a:avLst/>
           </a:prstGeom>
-        </p:spPr>
-      </p:pic>
+          <a:noFill/>
+        </p:spPr>
+        <p:txBody>
+          <a:bodyPr wrap="square">
+            <a:spAutoFit/>
+          </a:bodyPr>
+          <a:lstStyle/>
+          <a:p>
+            <a:pPr marL="0" indent="0" algn="ctr">
+              <a:buNone/>
+            </a:pPr>
+            <a:r>
+              <a:rPr lang="en-US" sz="2400" dirty="0">
+                <a:latin typeface="Calibri" pitchFamily="34" charset="0"/>
+                <a:ea typeface="Calibri" pitchFamily="34" charset="-122"/>
+                <a:cs typeface="Calibri" pitchFamily="34" charset="-120"/>
+              </a:rPr>
+              <a:t>→</a:t>
+            </a:r>
+            <a:endParaRPr lang="en-US" sz="2400" dirty="0"/>
+          </a:p>
+        </p:txBody>
+      </p:sp>
     </p:spTree>
   </p:cSld>
   <p:clrMapOvr>

</xml_diff>

<commit_message>
Update: Versión de la presentación del TFG revisada por el tutor (falta añadir el vídeo de respaldo por si falla la app)
</commit_message>
<xml_diff>
--- a/TFG_Chollos/Presentacion_Defensa_TFG.pptx
+++ b/TFG_Chollos/Presentacion_Defensa_TFG.pptx
@@ -3972,456 +3972,6 @@
       </p:sp>
       <p:sp>
         <p:nvSpPr>
-          <p:cNvPr id="6" name="Shape 4"/>
-          <p:cNvSpPr/>
-          <p:nvPr/>
-        </p:nvSpPr>
-        <p:spPr>
-          <a:xfrm>
-            <a:off x="548640" y="5623560"/>
-            <a:ext cx="420624" cy="420624"/>
-          </a:xfrm>
-          <a:prstGeom prst="ellipse">
-            <a:avLst/>
-          </a:prstGeom>
-          <a:solidFill>
-            <a:srgbClr val="3B6E77"/>
-          </a:solidFill>
-          <a:ln/>
-        </p:spPr>
-        <p:txBody>
-          <a:bodyPr/>
-          <a:lstStyle/>
-          <a:p>
-            <a:endParaRPr/>
-          </a:p>
-        </p:txBody>
-      </p:sp>
-      <p:pic>
-        <p:nvPicPr>
-          <p:cNvPr id="7" name="Image 0" descr="preencoded.png"/>
-          <p:cNvPicPr>
-            <a:picLocks noChangeAspect="1"/>
-          </p:cNvPicPr>
-          <p:nvPr/>
-        </p:nvPicPr>
-        <p:blipFill>
-          <a:blip r:embed="rId3"/>
-          <a:stretch>
-            <a:fillRect/>
-          </a:stretch>
-        </p:blipFill>
-        <p:spPr>
-          <a:xfrm>
-            <a:off x="640080" y="5715000"/>
-            <a:ext cx="237744" cy="237744"/>
-          </a:xfrm>
-          <a:prstGeom prst="rect">
-            <a:avLst/>
-          </a:prstGeom>
-        </p:spPr>
-      </p:pic>
-      <p:sp>
-        <p:nvSpPr>
-          <p:cNvPr id="8" name="Text 5"/>
-          <p:cNvSpPr/>
-          <p:nvPr/>
-        </p:nvSpPr>
-        <p:spPr>
-          <a:xfrm>
-            <a:off x="320040" y="6080760"/>
-            <a:ext cx="877824" cy="274320"/>
-          </a:xfrm>
-          <a:prstGeom prst="rect">
-            <a:avLst/>
-          </a:prstGeom>
-          <a:noFill/>
-          <a:ln/>
-        </p:spPr>
-        <p:txBody>
-          <a:bodyPr wrap="square" lIns="0" tIns="0" rIns="0" bIns="0" rtlCol="0" anchor="ctr"/>
-          <a:lstStyle/>
-          <a:p>
-            <a:pPr marL="0" indent="0" algn="ctr">
-              <a:buNone/>
-            </a:pPr>
-            <a:r>
-              <a:rPr lang="en-US" sz="900" dirty="0">
-                <a:solidFill>
-                  <a:srgbClr val="7A6F68"/>
-                </a:solidFill>
-                <a:latin typeface="Calibri" pitchFamily="34" charset="0"/>
-                <a:ea typeface="Calibri" pitchFamily="34" charset="-122"/>
-                <a:cs typeface="Calibri" pitchFamily="34" charset="-120"/>
-              </a:rPr>
-              <a:t>Selenium</a:t>
-            </a:r>
-            <a:endParaRPr lang="en-US" sz="900" dirty="0"/>
-          </a:p>
-        </p:txBody>
-      </p:sp>
-      <p:sp>
-        <p:nvSpPr>
-          <p:cNvPr id="9" name="Shape 6"/>
-          <p:cNvSpPr/>
-          <p:nvPr/>
-        </p:nvSpPr>
-        <p:spPr>
-          <a:xfrm>
-            <a:off x="1600200" y="5623560"/>
-            <a:ext cx="420624" cy="420624"/>
-          </a:xfrm>
-          <a:prstGeom prst="ellipse">
-            <a:avLst/>
-          </a:prstGeom>
-          <a:solidFill>
-            <a:srgbClr val="3B6E77"/>
-          </a:solidFill>
-          <a:ln/>
-        </p:spPr>
-        <p:txBody>
-          <a:bodyPr/>
-          <a:lstStyle/>
-          <a:p>
-            <a:endParaRPr/>
-          </a:p>
-        </p:txBody>
-      </p:sp>
-      <p:pic>
-        <p:nvPicPr>
-          <p:cNvPr id="10" name="Image 1" descr="preencoded.png"/>
-          <p:cNvPicPr>
-            <a:picLocks noChangeAspect="1"/>
-          </p:cNvPicPr>
-          <p:nvPr/>
-        </p:nvPicPr>
-        <p:blipFill>
-          <a:blip r:embed="rId4"/>
-          <a:stretch>
-            <a:fillRect/>
-          </a:stretch>
-        </p:blipFill>
-        <p:spPr>
-          <a:xfrm>
-            <a:off x="1691640" y="5715000"/>
-            <a:ext cx="237744" cy="237744"/>
-          </a:xfrm>
-          <a:prstGeom prst="rect">
-            <a:avLst/>
-          </a:prstGeom>
-        </p:spPr>
-      </p:pic>
-      <p:sp>
-        <p:nvSpPr>
-          <p:cNvPr id="11" name="Text 7"/>
-          <p:cNvSpPr/>
-          <p:nvPr/>
-        </p:nvSpPr>
-        <p:spPr>
-          <a:xfrm>
-            <a:off x="1371600" y="6080760"/>
-            <a:ext cx="877824" cy="274320"/>
-          </a:xfrm>
-          <a:prstGeom prst="rect">
-            <a:avLst/>
-          </a:prstGeom>
-          <a:noFill/>
-          <a:ln/>
-        </p:spPr>
-        <p:txBody>
-          <a:bodyPr wrap="square" lIns="0" tIns="0" rIns="0" bIns="0" rtlCol="0" anchor="ctr"/>
-          <a:lstStyle/>
-          <a:p>
-            <a:pPr marL="0" indent="0" algn="ctr">
-              <a:buNone/>
-            </a:pPr>
-            <a:r>
-              <a:rPr lang="en-US" sz="900" dirty="0">
-                <a:solidFill>
-                  <a:srgbClr val="7A6F68"/>
-                </a:solidFill>
-                <a:latin typeface="Calibri" pitchFamily="34" charset="0"/>
-                <a:ea typeface="Calibri" pitchFamily="34" charset="-122"/>
-                <a:cs typeface="Calibri" pitchFamily="34" charset="-120"/>
-              </a:rPr>
-              <a:t>Playwright</a:t>
-            </a:r>
-            <a:endParaRPr lang="en-US" sz="900" dirty="0"/>
-          </a:p>
-        </p:txBody>
-      </p:sp>
-      <p:sp>
-        <p:nvSpPr>
-          <p:cNvPr id="12" name="Shape 8"/>
-          <p:cNvSpPr/>
-          <p:nvPr/>
-        </p:nvSpPr>
-        <p:spPr>
-          <a:xfrm>
-            <a:off x="2651760" y="5623560"/>
-            <a:ext cx="420624" cy="420624"/>
-          </a:xfrm>
-          <a:prstGeom prst="ellipse">
-            <a:avLst/>
-          </a:prstGeom>
-          <a:solidFill>
-            <a:srgbClr val="3B6E77"/>
-          </a:solidFill>
-          <a:ln/>
-        </p:spPr>
-        <p:txBody>
-          <a:bodyPr/>
-          <a:lstStyle/>
-          <a:p>
-            <a:endParaRPr/>
-          </a:p>
-        </p:txBody>
-      </p:sp>
-      <p:pic>
-        <p:nvPicPr>
-          <p:cNvPr id="13" name="Image 2" descr="preencoded.png"/>
-          <p:cNvPicPr>
-            <a:picLocks noChangeAspect="1"/>
-          </p:cNvPicPr>
-          <p:nvPr/>
-        </p:nvPicPr>
-        <p:blipFill>
-          <a:blip r:embed="rId5"/>
-          <a:stretch>
-            <a:fillRect/>
-          </a:stretch>
-        </p:blipFill>
-        <p:spPr>
-          <a:xfrm>
-            <a:off x="2743200" y="5715000"/>
-            <a:ext cx="237744" cy="237744"/>
-          </a:xfrm>
-          <a:prstGeom prst="rect">
-            <a:avLst/>
-          </a:prstGeom>
-        </p:spPr>
-      </p:pic>
-      <p:sp>
-        <p:nvSpPr>
-          <p:cNvPr id="14" name="Text 9"/>
-          <p:cNvSpPr/>
-          <p:nvPr/>
-        </p:nvSpPr>
-        <p:spPr>
-          <a:xfrm>
-            <a:off x="2423160" y="6080760"/>
-            <a:ext cx="877824" cy="274320"/>
-          </a:xfrm>
-          <a:prstGeom prst="rect">
-            <a:avLst/>
-          </a:prstGeom>
-          <a:noFill/>
-          <a:ln/>
-        </p:spPr>
-        <p:txBody>
-          <a:bodyPr wrap="square" lIns="0" tIns="0" rIns="0" bIns="0" rtlCol="0" anchor="ctr"/>
-          <a:lstStyle/>
-          <a:p>
-            <a:pPr marL="0" indent="0" algn="ctr">
-              <a:buNone/>
-            </a:pPr>
-            <a:r>
-              <a:rPr lang="en-US" sz="900" dirty="0">
-                <a:solidFill>
-                  <a:srgbClr val="7A6F68"/>
-                </a:solidFill>
-                <a:latin typeface="Calibri" pitchFamily="34" charset="0"/>
-                <a:ea typeface="Calibri" pitchFamily="34" charset="-122"/>
-                <a:cs typeface="Calibri" pitchFamily="34" charset="-120"/>
-              </a:rPr>
-              <a:t>scikit-learn</a:t>
-            </a:r>
-            <a:endParaRPr lang="en-US" sz="900" dirty="0"/>
-          </a:p>
-        </p:txBody>
-      </p:sp>
-      <p:sp>
-        <p:nvSpPr>
-          <p:cNvPr id="15" name="Shape 10"/>
-          <p:cNvSpPr/>
-          <p:nvPr/>
-        </p:nvSpPr>
-        <p:spPr>
-          <a:xfrm>
-            <a:off x="3703320" y="5623560"/>
-            <a:ext cx="420624" cy="420624"/>
-          </a:xfrm>
-          <a:prstGeom prst="ellipse">
-            <a:avLst/>
-          </a:prstGeom>
-          <a:solidFill>
-            <a:srgbClr val="3B6E77"/>
-          </a:solidFill>
-          <a:ln/>
-        </p:spPr>
-        <p:txBody>
-          <a:bodyPr/>
-          <a:lstStyle/>
-          <a:p>
-            <a:endParaRPr/>
-          </a:p>
-        </p:txBody>
-      </p:sp>
-      <p:pic>
-        <p:nvPicPr>
-          <p:cNvPr id="16" name="Image 3" descr="preencoded.png"/>
-          <p:cNvPicPr>
-            <a:picLocks noChangeAspect="1"/>
-          </p:cNvPicPr>
-          <p:nvPr/>
-        </p:nvPicPr>
-        <p:blipFill>
-          <a:blip r:embed="rId6"/>
-          <a:stretch>
-            <a:fillRect/>
-          </a:stretch>
-        </p:blipFill>
-        <p:spPr>
-          <a:xfrm>
-            <a:off x="3794760" y="5715000"/>
-            <a:ext cx="237744" cy="237744"/>
-          </a:xfrm>
-          <a:prstGeom prst="rect">
-            <a:avLst/>
-          </a:prstGeom>
-        </p:spPr>
-      </p:pic>
-      <p:sp>
-        <p:nvSpPr>
-          <p:cNvPr id="17" name="Text 11"/>
-          <p:cNvSpPr/>
-          <p:nvPr/>
-        </p:nvSpPr>
-        <p:spPr>
-          <a:xfrm>
-            <a:off x="3474720" y="6080760"/>
-            <a:ext cx="877824" cy="274320"/>
-          </a:xfrm>
-          <a:prstGeom prst="rect">
-            <a:avLst/>
-          </a:prstGeom>
-          <a:noFill/>
-          <a:ln/>
-        </p:spPr>
-        <p:txBody>
-          <a:bodyPr wrap="square" lIns="0" tIns="0" rIns="0" bIns="0" rtlCol="0" anchor="ctr"/>
-          <a:lstStyle/>
-          <a:p>
-            <a:pPr marL="0" indent="0" algn="ctr">
-              <a:buNone/>
-            </a:pPr>
-            <a:r>
-              <a:rPr lang="en-US" sz="900" dirty="0">
-                <a:solidFill>
-                  <a:srgbClr val="7A6F68"/>
-                </a:solidFill>
-                <a:latin typeface="Calibri" pitchFamily="34" charset="0"/>
-                <a:ea typeface="Calibri" pitchFamily="34" charset="-122"/>
-                <a:cs typeface="Calibri" pitchFamily="34" charset="-120"/>
-              </a:rPr>
-              <a:t>XGBoost</a:t>
-            </a:r>
-            <a:endParaRPr lang="en-US" sz="900" dirty="0"/>
-          </a:p>
-        </p:txBody>
-      </p:sp>
-      <p:sp>
-        <p:nvSpPr>
-          <p:cNvPr id="18" name="Shape 12"/>
-          <p:cNvSpPr/>
-          <p:nvPr/>
-        </p:nvSpPr>
-        <p:spPr>
-          <a:xfrm>
-            <a:off x="4754880" y="5623560"/>
-            <a:ext cx="420624" cy="420624"/>
-          </a:xfrm>
-          <a:prstGeom prst="ellipse">
-            <a:avLst/>
-          </a:prstGeom>
-          <a:solidFill>
-            <a:srgbClr val="3B6E77"/>
-          </a:solidFill>
-          <a:ln/>
-        </p:spPr>
-        <p:txBody>
-          <a:bodyPr/>
-          <a:lstStyle/>
-          <a:p>
-            <a:endParaRPr/>
-          </a:p>
-        </p:txBody>
-      </p:sp>
-      <p:pic>
-        <p:nvPicPr>
-          <p:cNvPr id="19" name="Image 4" descr="preencoded.png"/>
-          <p:cNvPicPr>
-            <a:picLocks noChangeAspect="1"/>
-          </p:cNvPicPr>
-          <p:nvPr/>
-        </p:nvPicPr>
-        <p:blipFill>
-          <a:blip r:embed="rId7"/>
-          <a:stretch>
-            <a:fillRect/>
-          </a:stretch>
-        </p:blipFill>
-        <p:spPr>
-          <a:xfrm>
-            <a:off x="4846320" y="5715000"/>
-            <a:ext cx="237744" cy="237744"/>
-          </a:xfrm>
-          <a:prstGeom prst="rect">
-            <a:avLst/>
-          </a:prstGeom>
-        </p:spPr>
-      </p:pic>
-      <p:sp>
-        <p:nvSpPr>
-          <p:cNvPr id="20" name="Text 13"/>
-          <p:cNvSpPr/>
-          <p:nvPr/>
-        </p:nvSpPr>
-        <p:spPr>
-          <a:xfrm>
-            <a:off x="4526280" y="6080760"/>
-            <a:ext cx="877824" cy="274320"/>
-          </a:xfrm>
-          <a:prstGeom prst="rect">
-            <a:avLst/>
-          </a:prstGeom>
-          <a:noFill/>
-          <a:ln/>
-        </p:spPr>
-        <p:txBody>
-          <a:bodyPr wrap="square" lIns="0" tIns="0" rIns="0" bIns="0" rtlCol="0" anchor="ctr"/>
-          <a:lstStyle/>
-          <a:p>
-            <a:pPr marL="0" indent="0" algn="ctr">
-              <a:buNone/>
-            </a:pPr>
-            <a:r>
-              <a:rPr lang="en-US" sz="900" dirty="0">
-                <a:solidFill>
-                  <a:srgbClr val="7A6F68"/>
-                </a:solidFill>
-                <a:latin typeface="Calibri" pitchFamily="34" charset="0"/>
-                <a:ea typeface="Calibri" pitchFamily="34" charset="-122"/>
-                <a:cs typeface="Calibri" pitchFamily="34" charset="-120"/>
-              </a:rPr>
-              <a:t>Streamlit</a:t>
-            </a:r>
-            <a:endParaRPr lang="en-US" sz="900" dirty="0"/>
-          </a:p>
-        </p:txBody>
-      </p:sp>
-      <p:sp>
-        <p:nvSpPr>
           <p:cNvPr id="21" name="Text 14"/>
           <p:cNvSpPr/>
           <p:nvPr/>
@@ -8334,7 +7884,7 @@
         <p:spPr>
           <a:xfrm>
             <a:off x="7150735" y="4063732"/>
-            <a:ext cx="4263719" cy="1018780"/>
+            <a:ext cx="4367975" cy="1018780"/>
           </a:xfrm>
           <a:prstGeom prst="rect">
             <a:avLst/>
@@ -8915,7 +8465,29 @@
                 <a:ea typeface="Calibri" pitchFamily="34" charset="-122"/>
                 <a:cs typeface="Calibri" pitchFamily="34" charset="-120"/>
               </a:rPr>
-              <a:t>Árbol de Decisión (CART)</a:t>
+              <a:t>Árbol de </a:t>
+            </a:r>
+            <a:r>
+              <a:rPr lang="en-US" sz="1450" b="1" dirty="0" err="1">
+                <a:solidFill>
+                  <a:srgbClr val="2B2320"/>
+                </a:solidFill>
+                <a:latin typeface="Calibri" pitchFamily="34" charset="0"/>
+                <a:ea typeface="Calibri" pitchFamily="34" charset="-122"/>
+                <a:cs typeface="Calibri" pitchFamily="34" charset="-120"/>
+              </a:rPr>
+              <a:t>Regresión</a:t>
+            </a:r>
+            <a:r>
+              <a:rPr lang="en-US" sz="1450" b="1" dirty="0">
+                <a:solidFill>
+                  <a:srgbClr val="2B2320"/>
+                </a:solidFill>
+                <a:latin typeface="Calibri" pitchFamily="34" charset="0"/>
+                <a:ea typeface="Calibri" pitchFamily="34" charset="-122"/>
+                <a:cs typeface="Calibri" pitchFamily="34" charset="-120"/>
+              </a:rPr>
+              <a:t> (CART)</a:t>
             </a:r>
             <a:endParaRPr lang="en-US" sz="1450" dirty="0"/>
           </a:p>
@@ -9554,7 +9126,7 @@
         <p:spPr>
           <a:xfrm>
             <a:off x="1316736" y="640080"/>
-            <a:ext cx="9966960" cy="640080"/>
+            <a:ext cx="9966960" cy="430887"/>
           </a:xfrm>
           <a:prstGeom prst="rect">
             <a:avLst/>
@@ -9569,14 +9141,29 @@
           <a:p>
             <a:pPr algn="l"/>
             <a:r>
-              <a:rPr sz="2800" b="1" i="0">
+              <a:rPr sz="2800" b="1" i="0" dirty="0">
                 <a:solidFill>
                   <a:srgbClr val="2B2320"/>
                 </a:solidFill>
                 <a:latin typeface="Cambria"/>
               </a:rPr>
-              <a:t>Árbol de decisión</a:t>
-            </a:r>
+              <a:t>Árbol de </a:t>
+            </a:r>
+            <a:r>
+              <a:rPr lang="es-ES" sz="2800" b="1" i="0" dirty="0">
+                <a:solidFill>
+                  <a:srgbClr val="2B2320"/>
+                </a:solidFill>
+                <a:latin typeface="Cambria"/>
+              </a:rPr>
+              <a:t>regresión</a:t>
+            </a:r>
+            <a:endParaRPr sz="2800" b="1" i="0" dirty="0">
+              <a:solidFill>
+                <a:srgbClr val="2B2320"/>
+              </a:solidFill>
+              <a:latin typeface="Cambria"/>
+            </a:endParaRPr>
           </a:p>
         </p:txBody>
       </p:sp>
@@ -9596,8 +9183,8 @@
         </p:blipFill>
         <p:spPr>
           <a:xfrm>
-            <a:off x="1115568" y="1019072"/>
-            <a:ext cx="9815886" cy="4925052"/>
+            <a:off x="1115568" y="1070966"/>
+            <a:ext cx="9815886" cy="4873157"/>
           </a:xfrm>
           <a:prstGeom prst="rect">
             <a:avLst/>
@@ -9613,7 +9200,7 @@
         <p:spPr>
           <a:xfrm>
             <a:off x="1280160" y="5944124"/>
-            <a:ext cx="9601200" cy="548640"/>
+            <a:ext cx="9601200" cy="353943"/>
           </a:xfrm>
           <a:prstGeom prst="rect">
             <a:avLst/>
@@ -9628,13 +9215,265 @@
           <a:p>
             <a:pPr algn="ctr"/>
             <a:r>
-              <a:rPr sz="1150" b="0" i="1">
+              <a:rPr sz="1150" b="0" i="1" dirty="0">
                 <a:solidFill>
                   <a:srgbClr val="7A6F68"/>
                 </a:solidFill>
                 <a:latin typeface="Calibri"/>
               </a:rPr>
-              <a:t>Uno de los cuatro modelos candidatos (Sección 4.3): el árbol de decisión particiona el espacio de características de forma recursiva. La raíz es tamaño_habitacion (≤ 75,5m²); el segundo nivel es provincia.</a:t>
+              <a:t>Uno de </a:t>
+            </a:r>
+            <a:r>
+              <a:rPr sz="1150" b="0" i="1" dirty="0" err="1">
+                <a:solidFill>
+                  <a:srgbClr val="7A6F68"/>
+                </a:solidFill>
+                <a:latin typeface="Calibri"/>
+              </a:rPr>
+              <a:t>los</a:t>
+            </a:r>
+            <a:r>
+              <a:rPr sz="1150" b="0" i="1" dirty="0">
+                <a:solidFill>
+                  <a:srgbClr val="7A6F68"/>
+                </a:solidFill>
+                <a:latin typeface="Calibri"/>
+              </a:rPr>
+              <a:t> cuatro </a:t>
+            </a:r>
+            <a:r>
+              <a:rPr sz="1150" b="0" i="1" dirty="0" err="1">
+                <a:solidFill>
+                  <a:srgbClr val="7A6F68"/>
+                </a:solidFill>
+                <a:latin typeface="Calibri"/>
+              </a:rPr>
+              <a:t>modelos</a:t>
+            </a:r>
+            <a:r>
+              <a:rPr sz="1150" b="0" i="1" dirty="0">
+                <a:solidFill>
+                  <a:srgbClr val="7A6F68"/>
+                </a:solidFill>
+                <a:latin typeface="Calibri"/>
+              </a:rPr>
+              <a:t> </a:t>
+            </a:r>
+            <a:r>
+              <a:rPr sz="1150" b="0" i="1" dirty="0" err="1">
+                <a:solidFill>
+                  <a:srgbClr val="7A6F68"/>
+                </a:solidFill>
+                <a:latin typeface="Calibri"/>
+              </a:rPr>
+              <a:t>candidatos</a:t>
+            </a:r>
+            <a:r>
+              <a:rPr sz="1150" b="0" i="1" dirty="0">
+                <a:solidFill>
+                  <a:srgbClr val="7A6F68"/>
+                </a:solidFill>
+                <a:latin typeface="Calibri"/>
+              </a:rPr>
+              <a:t> (</a:t>
+            </a:r>
+            <a:r>
+              <a:rPr sz="1150" b="0" i="1" dirty="0" err="1">
+                <a:solidFill>
+                  <a:srgbClr val="7A6F68"/>
+                </a:solidFill>
+                <a:latin typeface="Calibri"/>
+              </a:rPr>
+              <a:t>Sección</a:t>
+            </a:r>
+            <a:r>
+              <a:rPr sz="1150" b="0" i="1" dirty="0">
+                <a:solidFill>
+                  <a:srgbClr val="7A6F68"/>
+                </a:solidFill>
+                <a:latin typeface="Calibri"/>
+              </a:rPr>
+              <a:t> 4.3): el árbol de </a:t>
+            </a:r>
+            <a:r>
+              <a:rPr lang="es-ES" sz="1150" b="0" i="1" dirty="0">
+                <a:solidFill>
+                  <a:srgbClr val="7A6F68"/>
+                </a:solidFill>
+                <a:latin typeface="Calibri"/>
+              </a:rPr>
+              <a:t>regresión</a:t>
+            </a:r>
+            <a:r>
+              <a:rPr sz="1150" b="0" i="1" dirty="0">
+                <a:solidFill>
+                  <a:srgbClr val="7A6F68"/>
+                </a:solidFill>
+                <a:latin typeface="Calibri"/>
+              </a:rPr>
+              <a:t> </a:t>
+            </a:r>
+            <a:r>
+              <a:rPr sz="1150" b="0" i="1" dirty="0" err="1">
+                <a:solidFill>
+                  <a:srgbClr val="7A6F68"/>
+                </a:solidFill>
+                <a:latin typeface="Calibri"/>
+              </a:rPr>
+              <a:t>particiona</a:t>
+            </a:r>
+            <a:r>
+              <a:rPr sz="1150" b="0" i="1" dirty="0">
+                <a:solidFill>
+                  <a:srgbClr val="7A6F68"/>
+                </a:solidFill>
+                <a:latin typeface="Calibri"/>
+              </a:rPr>
+              <a:t> el </a:t>
+            </a:r>
+            <a:r>
+              <a:rPr sz="1150" b="0" i="1" dirty="0" err="1">
+                <a:solidFill>
+                  <a:srgbClr val="7A6F68"/>
+                </a:solidFill>
+                <a:latin typeface="Calibri"/>
+              </a:rPr>
+              <a:t>espacio</a:t>
+            </a:r>
+            <a:r>
+              <a:rPr sz="1150" b="0" i="1" dirty="0">
+                <a:solidFill>
+                  <a:srgbClr val="7A6F68"/>
+                </a:solidFill>
+                <a:latin typeface="Calibri"/>
+              </a:rPr>
+              <a:t> de </a:t>
+            </a:r>
+            <a:r>
+              <a:rPr sz="1150" b="0" i="1" dirty="0" err="1">
+                <a:solidFill>
+                  <a:srgbClr val="7A6F68"/>
+                </a:solidFill>
+                <a:latin typeface="Calibri"/>
+              </a:rPr>
+              <a:t>características</a:t>
+            </a:r>
+            <a:r>
+              <a:rPr sz="1150" b="0" i="1" dirty="0">
+                <a:solidFill>
+                  <a:srgbClr val="7A6F68"/>
+                </a:solidFill>
+                <a:latin typeface="Calibri"/>
+              </a:rPr>
+              <a:t> de forma </a:t>
+            </a:r>
+            <a:r>
+              <a:rPr sz="1150" b="0" i="1" dirty="0" err="1">
+                <a:solidFill>
+                  <a:srgbClr val="7A6F68"/>
+                </a:solidFill>
+                <a:latin typeface="Calibri"/>
+              </a:rPr>
+              <a:t>recursiva</a:t>
+            </a:r>
+            <a:r>
+              <a:rPr sz="1150" b="0" i="1" dirty="0">
+                <a:solidFill>
+                  <a:srgbClr val="7A6F68"/>
+                </a:solidFill>
+                <a:latin typeface="Calibri"/>
+              </a:rPr>
+              <a:t>. La </a:t>
+            </a:r>
+            <a:r>
+              <a:rPr sz="1150" b="0" i="1" dirty="0" err="1">
+                <a:solidFill>
+                  <a:srgbClr val="7A6F68"/>
+                </a:solidFill>
+                <a:latin typeface="Calibri"/>
+              </a:rPr>
+              <a:t>raíz</a:t>
+            </a:r>
+            <a:r>
+              <a:rPr sz="1150" b="0" i="1" dirty="0">
+                <a:solidFill>
+                  <a:srgbClr val="7A6F68"/>
+                </a:solidFill>
+                <a:latin typeface="Calibri"/>
+              </a:rPr>
+              <a:t> es </a:t>
+            </a:r>
+            <a:r>
+              <a:rPr sz="1150" b="0" i="1" dirty="0" err="1">
+                <a:solidFill>
+                  <a:srgbClr val="7A6F68"/>
+                </a:solidFill>
+                <a:latin typeface="Calibri"/>
+              </a:rPr>
+              <a:t>tamaño_habitacion</a:t>
+            </a:r>
+            <a:r>
+              <a:rPr sz="1150" b="0" i="1" dirty="0">
+                <a:solidFill>
+                  <a:srgbClr val="7A6F68"/>
+                </a:solidFill>
+                <a:latin typeface="Calibri"/>
+              </a:rPr>
+              <a:t> (≤ 75,5m²); el </a:t>
+            </a:r>
+            <a:r>
+              <a:rPr sz="1150" b="0" i="1" dirty="0" err="1">
+                <a:solidFill>
+                  <a:srgbClr val="7A6F68"/>
+                </a:solidFill>
+                <a:latin typeface="Calibri"/>
+              </a:rPr>
+              <a:t>segundo</a:t>
+            </a:r>
+            <a:r>
+              <a:rPr sz="1150" b="0" i="1" dirty="0">
+                <a:solidFill>
+                  <a:srgbClr val="7A6F68"/>
+                </a:solidFill>
+                <a:latin typeface="Calibri"/>
+              </a:rPr>
+              <a:t> </a:t>
+            </a:r>
+            <a:r>
+              <a:rPr sz="1150" b="0" i="1" dirty="0" err="1">
+                <a:solidFill>
+                  <a:srgbClr val="7A6F68"/>
+                </a:solidFill>
+                <a:latin typeface="Calibri"/>
+              </a:rPr>
+              <a:t>nivel</a:t>
+            </a:r>
+            <a:r>
+              <a:rPr sz="1150" b="0" i="1" dirty="0">
+                <a:solidFill>
+                  <a:srgbClr val="7A6F68"/>
+                </a:solidFill>
+                <a:latin typeface="Calibri"/>
+              </a:rPr>
+              <a:t> es </a:t>
+            </a:r>
+            <a:r>
+              <a:rPr sz="1150" b="0" i="1" dirty="0" err="1">
+                <a:solidFill>
+                  <a:srgbClr val="7A6F68"/>
+                </a:solidFill>
+                <a:latin typeface="Calibri"/>
+              </a:rPr>
+              <a:t>provincia</a:t>
+            </a:r>
+            <a:r>
+              <a:rPr sz="1150" b="0" i="1" dirty="0">
+                <a:solidFill>
+                  <a:srgbClr val="7A6F68"/>
+                </a:solidFill>
+                <a:latin typeface="Calibri"/>
+              </a:rPr>
+              <a:t>.</a:t>
             </a:r>
           </a:p>
         </p:txBody>
@@ -9888,7 +9727,7 @@
           <p:nvPr>
             <p:extLst>
               <p:ext uri="{D42A27DB-BD31-4B8C-83A1-F6EECF244321}">
-                <p14:modId xmlns:p14="http://schemas.microsoft.com/office/powerpoint/2010/main" val="596502264"/>
+                <p14:modId xmlns:p14="http://schemas.microsoft.com/office/powerpoint/2010/main" val="3565569378"/>
               </p:ext>
             </p:extLst>
           </p:nvPr>
@@ -10762,7 +10601,18 @@
                           <a:ea typeface="Calibri" pitchFamily="34" charset="-122"/>
                           <a:cs typeface="Calibri" pitchFamily="34" charset="-120"/>
                         </a:rPr>
-                        <a:t>Árbol de decisión</a:t>
+                        <a:t>Árbol de </a:t>
+                      </a:r>
+                      <a:r>
+                        <a:rPr lang="en-US" sz="1300" dirty="0" err="1">
+                          <a:solidFill>
+                            <a:srgbClr val="2B2320"/>
+                          </a:solidFill>
+                          <a:latin typeface="Calibri" pitchFamily="34" charset="0"/>
+                          <a:ea typeface="Calibri" pitchFamily="34" charset="-122"/>
+                          <a:cs typeface="Calibri" pitchFamily="34" charset="-120"/>
+                        </a:rPr>
+                        <a:t>regresión</a:t>
                       </a:r>
                       <a:endParaRPr lang="en-US" sz="1300" dirty="0">
                         <a:latin typeface="Calibri" charset="0"/>
@@ -11672,7 +11522,7 @@
         <p:spPr>
           <a:xfrm>
             <a:off x="7754111" y="4709160"/>
-            <a:ext cx="3749040" cy="1280160"/>
+            <a:ext cx="3888944" cy="1280160"/>
           </a:xfrm>
           <a:prstGeom prst="rect">
             <a:avLst/>
@@ -14479,7 +14329,7 @@
         <p:spPr>
           <a:xfrm>
             <a:off x="6492240" y="1554480"/>
-            <a:ext cx="5120640" cy="1645920"/>
+            <a:ext cx="5120640" cy="1800000"/>
           </a:xfrm>
           <a:prstGeom prst="roundRect">
             <a:avLst>
@@ -14514,8 +14364,8 @@
         </p:nvSpPr>
         <p:spPr>
           <a:xfrm>
-            <a:off x="6629400" y="1664208"/>
-            <a:ext cx="4846320" cy="905256"/>
+            <a:off x="6629400" y="1706880"/>
+            <a:ext cx="4846320" cy="800100"/>
           </a:xfrm>
           <a:prstGeom prst="rect">
             <a:avLst/>
@@ -14553,8 +14403,8 @@
         </p:nvSpPr>
         <p:spPr>
           <a:xfrm>
-            <a:off x="6629400" y="2574950"/>
-            <a:ext cx="4983480" cy="592531"/>
+            <a:off x="6629400" y="2560320"/>
+            <a:ext cx="4983480" cy="411480"/>
           </a:xfrm>
           <a:prstGeom prst="rect">
             <a:avLst/>
@@ -14578,51 +14428,7 @@
                 <a:ea typeface="Calibri" pitchFamily="34" charset="-122"/>
                 <a:cs typeface="Calibri" pitchFamily="34" charset="-120"/>
               </a:rPr>
-              <a:t>de los alojamientos del conjunto de </a:t>
-            </a:r>
-            <a:r>
-              <a:rPr lang="en-US" sz="1050" dirty="0" err="1">
-                <a:solidFill>
-                  <a:srgbClr val="7A6F68"/>
-                </a:solidFill>
-                <a:latin typeface="Calibri" pitchFamily="34" charset="0"/>
-                <a:ea typeface="Calibri" pitchFamily="34" charset="-122"/>
-                <a:cs typeface="Calibri" pitchFamily="34" charset="-120"/>
-              </a:rPr>
-              <a:t>prueba</a:t>
-            </a:r>
-            <a:r>
-              <a:rPr lang="en-US" sz="1050" dirty="0">
-                <a:solidFill>
-                  <a:srgbClr val="7A6F68"/>
-                </a:solidFill>
-                <a:latin typeface="Calibri" pitchFamily="34" charset="0"/>
-                <a:ea typeface="Calibri" pitchFamily="34" charset="-122"/>
-                <a:cs typeface="Calibri" pitchFamily="34" charset="-120"/>
-              </a:rPr>
-              <a:t> </a:t>
-            </a:r>
-            <a:r>
-              <a:rPr lang="en-US" sz="1050" dirty="0" err="1">
-                <a:solidFill>
-                  <a:srgbClr val="7A6F68"/>
-                </a:solidFill>
-                <a:latin typeface="Calibri" pitchFamily="34" charset="0"/>
-                <a:ea typeface="Calibri" pitchFamily="34" charset="-122"/>
-                <a:cs typeface="Calibri" pitchFamily="34" charset="-120"/>
-              </a:rPr>
-              <a:t>constituyen</a:t>
-            </a:r>
-            <a:r>
-              <a:rPr lang="en-US" sz="1050" dirty="0">
-                <a:solidFill>
-                  <a:srgbClr val="7A6F68"/>
-                </a:solidFill>
-                <a:latin typeface="Calibri" pitchFamily="34" charset="0"/>
-                <a:ea typeface="Calibri" pitchFamily="34" charset="-122"/>
-                <a:cs typeface="Calibri" pitchFamily="34" charset="-120"/>
-              </a:rPr>
-              <a:t> un chollo (Chollo + Super + Hiper)</a:t>
+              <a:t>son un chollo (Chollo + Super + Hiper)</a:t>
             </a:r>
             <a:endParaRPr lang="en-US" sz="1050" dirty="0"/>
           </a:p>
@@ -15906,8 +15712,8 @@
         </p:nvSpPr>
         <p:spPr>
           <a:xfrm>
-            <a:off x="6787804" y="1847088"/>
-            <a:ext cx="5120640" cy="274320"/>
+            <a:off x="6787804" y="3017520"/>
+            <a:ext cx="5120640" cy="228600"/>
           </a:xfrm>
           <a:prstGeom prst="rect">
             <a:avLst/>
@@ -15923,7 +15729,7 @@
               <a:buNone/>
             </a:pPr>
             <a:r>
-              <a:rPr lang="en-US" sz="1050" i="1" dirty="0">
+              <a:rPr lang="en-US" sz="900" i="1" dirty="0">
                 <a:solidFill>
                   <a:srgbClr val="7A6F68"/>
                 </a:solidFill>
@@ -15931,40 +15737,7 @@
                 <a:ea typeface="Calibri" pitchFamily="34" charset="-122"/>
                 <a:cs typeface="Calibri" pitchFamily="34" charset="-120"/>
               </a:rPr>
-              <a:t>Sobre 390.462 registros del conjunto de </a:t>
-            </a:r>
-            <a:r>
-              <a:rPr lang="en-US" sz="1050" i="1" dirty="0" err="1">
-                <a:solidFill>
-                  <a:srgbClr val="7A6F68"/>
-                </a:solidFill>
-                <a:latin typeface="Calibri" pitchFamily="34" charset="0"/>
-                <a:ea typeface="Calibri" pitchFamily="34" charset="-122"/>
-                <a:cs typeface="Calibri" pitchFamily="34" charset="-120"/>
-              </a:rPr>
-              <a:t>prueba</a:t>
-            </a:r>
-            <a:r>
-              <a:rPr lang="en-US" sz="1050" i="1" dirty="0">
-                <a:solidFill>
-                  <a:srgbClr val="7A6F68"/>
-                </a:solidFill>
-                <a:latin typeface="Calibri" pitchFamily="34" charset="0"/>
-                <a:ea typeface="Calibri" pitchFamily="34" charset="-122"/>
-                <a:cs typeface="Calibri" pitchFamily="34" charset="-120"/>
-              </a:rPr>
-              <a:t>, </a:t>
-            </a:r>
-            <a:r>
-              <a:rPr lang="en-US" sz="1050" i="1" dirty="0" err="1">
-                <a:solidFill>
-                  <a:srgbClr val="7A6F68"/>
-                </a:solidFill>
-                <a:latin typeface="Calibri" pitchFamily="34" charset="0"/>
-                <a:ea typeface="Calibri" pitchFamily="34" charset="-122"/>
-                <a:cs typeface="Calibri" pitchFamily="34" charset="-120"/>
-              </a:rPr>
-              <a:t>el</a:t>
+              <a:t>390.462 registros del conjunto de prueba</a:t>
             </a:r>
             <a:endParaRPr lang="en-US" sz="1050" dirty="0"/>
           </a:p>
@@ -17160,7 +16933,18 @@
                 <a:ea typeface="Cambria" pitchFamily="34" charset="-122"/>
                 <a:cs typeface="Cambria" pitchFamily="34" charset="-120"/>
               </a:rPr>
-              <a:t>Flujo de trabajo de la búsqueda</a:t>
+              <a:t>Flujo de trabajo de la </a:t>
+            </a:r>
+            <a:r>
+              <a:rPr lang="en-US" sz="2800" b="1">
+                <a:solidFill>
+                  <a:srgbClr val="2B2320"/>
+                </a:solidFill>
+                <a:latin typeface="Cambria" pitchFamily="34" charset="0"/>
+                <a:ea typeface="Cambria" pitchFamily="34" charset="-122"/>
+                <a:cs typeface="Cambria" pitchFamily="34" charset="-120"/>
+              </a:rPr>
+              <a:t>aplicación</a:t>
             </a:r>
             <a:endParaRPr lang="en-US" sz="2800" dirty="0"/>
           </a:p>
@@ -17742,9 +17526,7 @@
           <a:bodyPr wrap="square" lIns="0" tIns="0" rIns="0" bIns="0" rtlCol="0" anchor="ctr"/>
           <a:lstStyle/>
           <a:p>
-            <a:pPr marL="0" indent="0" algn="ctr">
-              <a:buNone/>
-            </a:pPr>
+            <a:pPr algn="ctr"/>
             <a:r>
               <a:rPr lang="en-US" sz="1400" b="1" dirty="0">
                 <a:solidFill>
@@ -17864,33 +17646,6 @@
       </p:sp>
       <p:sp>
         <p:nvSpPr>
-          <p:cNvPr id="28" name="Shape 21"/>
-          <p:cNvSpPr/>
-          <p:nvPr/>
-        </p:nvSpPr>
-        <p:spPr>
-          <a:xfrm>
-            <a:off x="548640" y="4590288"/>
-            <a:ext cx="457200" cy="457200"/>
-          </a:xfrm>
-          <a:prstGeom prst="ellipse">
-            <a:avLst/>
-          </a:prstGeom>
-          <a:solidFill>
-            <a:srgbClr val="B8563A"/>
-          </a:solidFill>
-          <a:ln/>
-        </p:spPr>
-        <p:txBody>
-          <a:bodyPr/>
-          <a:lstStyle/>
-          <a:p>
-            <a:endParaRPr/>
-          </a:p>
-        </p:txBody>
-      </p:sp>
-      <p:sp>
-        <p:nvSpPr>
           <p:cNvPr id="29" name="Text 22"/>
           <p:cNvSpPr/>
           <p:nvPr/>
@@ -18195,6 +17950,55 @@
               <a:t>Tabla ordenada por ahorro y gráfico de categorías</a:t>
             </a:r>
             <a:endParaRPr lang="en-US" sz="1200" dirty="0"/>
+          </a:p>
+        </p:txBody>
+      </p:sp>
+      <p:sp>
+        <p:nvSpPr>
+          <p:cNvPr id="39" name="Shape 17">
+            <a:extLst>
+              <a:ext uri="{FF2B5EF4-FFF2-40B4-BE49-F238E27FC236}">
+                <a16:creationId xmlns:a16="http://schemas.microsoft.com/office/drawing/2014/main" id="{DE033A3F-F28A-8445-EE73-3FE5D95C9782}"/>
+              </a:ext>
+            </a:extLst>
+          </p:cNvPr>
+          <p:cNvSpPr/>
+          <p:nvPr/>
+        </p:nvSpPr>
+        <p:spPr>
+          <a:xfrm>
+            <a:off x="545092" y="4594860"/>
+            <a:ext cx="457200" cy="457200"/>
+          </a:xfrm>
+          <a:prstGeom prst="ellipse">
+            <a:avLst/>
+          </a:prstGeom>
+          <a:solidFill>
+            <a:srgbClr val="3B6E77"/>
+          </a:solidFill>
+          <a:ln/>
+        </p:spPr>
+        <p:txBody>
+          <a:bodyPr/>
+          <a:lstStyle/>
+          <a:p>
+            <a:r>
+              <a:rPr lang="es-ES" sz="1400" dirty="0">
+                <a:solidFill>
+                  <a:schemeClr val="bg1"/>
+                </a:solidFill>
+                <a:latin typeface="Cambria" panose="02040503050406030204" pitchFamily="18" charset="0"/>
+                <a:ea typeface="Cambria" panose="02040503050406030204" pitchFamily="18" charset="0"/>
+              </a:rPr>
+              <a:t>5</a:t>
+            </a:r>
+            <a:endParaRPr sz="1400" dirty="0">
+              <a:solidFill>
+                <a:schemeClr val="bg1"/>
+              </a:solidFill>
+              <a:latin typeface="Cambria" panose="02040503050406030204" pitchFamily="18" charset="0"/>
+              <a:ea typeface="Cambria" panose="02040503050406030204" pitchFamily="18" charset="0"/>
+            </a:endParaRPr>
           </a:p>
         </p:txBody>
       </p:sp>
@@ -18488,7 +18292,7 @@
         </p:nvSpPr>
         <p:spPr>
           <a:xfrm>
-            <a:off x="1325880" y="1362456"/>
+            <a:off x="1325880" y="1485900"/>
             <a:ext cx="7772400" cy="365760"/>
           </a:xfrm>
           <a:prstGeom prst="rect">
@@ -18516,45 +18320,6 @@
               <a:t>Motivación y objetivos</a:t>
             </a:r>
             <a:endParaRPr lang="en-US" sz="1650" dirty="0"/>
-          </a:p>
-        </p:txBody>
-      </p:sp>
-      <p:sp>
-        <p:nvSpPr>
-          <p:cNvPr id="10" name="Text 8"/>
-          <p:cNvSpPr/>
-          <p:nvPr/>
-        </p:nvSpPr>
-        <p:spPr>
-          <a:xfrm>
-            <a:off x="1325880" y="1709928"/>
-            <a:ext cx="8686800" cy="320040"/>
-          </a:xfrm>
-          <a:prstGeom prst="rect">
-            <a:avLst/>
-          </a:prstGeom>
-          <a:noFill/>
-          <a:ln/>
-        </p:spPr>
-        <p:txBody>
-          <a:bodyPr wrap="square" lIns="0" tIns="0" rIns="0" bIns="0" rtlCol="0" anchor="ctr"/>
-          <a:lstStyle/>
-          <a:p>
-            <a:pPr marL="0" indent="0">
-              <a:buNone/>
-            </a:pPr>
-            <a:r>
-              <a:rPr lang="en-US" sz="1150" dirty="0">
-                <a:solidFill>
-                  <a:srgbClr val="7A6F68"/>
-                </a:solidFill>
-                <a:latin typeface="Calibri" pitchFamily="34" charset="0"/>
-                <a:ea typeface="Calibri" pitchFamily="34" charset="-122"/>
-                <a:cs typeface="Calibri" pitchFamily="34" charset="-120"/>
-              </a:rPr>
-              <a:t>Contexto del problema y alcance del trabajo</a:t>
-            </a:r>
-            <a:endParaRPr lang="en-US" sz="1150" dirty="0"/>
           </a:p>
         </p:txBody>
       </p:sp>
@@ -18632,7 +18397,7 @@
         </p:nvSpPr>
         <p:spPr>
           <a:xfrm>
-            <a:off x="1325880" y="2139696"/>
+            <a:off x="1325880" y="2263140"/>
             <a:ext cx="7772400" cy="365760"/>
           </a:xfrm>
           <a:prstGeom prst="rect">
@@ -18660,45 +18425,6 @@
               <a:t>Datos y metodología</a:t>
             </a:r>
             <a:endParaRPr lang="en-US" sz="1650" dirty="0"/>
-          </a:p>
-        </p:txBody>
-      </p:sp>
-      <p:sp>
-        <p:nvSpPr>
-          <p:cNvPr id="14" name="Text 12"/>
-          <p:cNvSpPr/>
-          <p:nvPr/>
-        </p:nvSpPr>
-        <p:spPr>
-          <a:xfrm>
-            <a:off x="1325880" y="2487168"/>
-            <a:ext cx="8686800" cy="320040"/>
-          </a:xfrm>
-          <a:prstGeom prst="rect">
-            <a:avLst/>
-          </a:prstGeom>
-          <a:noFill/>
-          <a:ln/>
-        </p:spPr>
-        <p:txBody>
-          <a:bodyPr wrap="square" lIns="0" tIns="0" rIns="0" bIns="0" rtlCol="0" anchor="ctr"/>
-          <a:lstStyle/>
-          <a:p>
-            <a:pPr marL="0" indent="0">
-              <a:buNone/>
-            </a:pPr>
-            <a:r>
-              <a:rPr lang="en-US" sz="1150" dirty="0">
-                <a:solidFill>
-                  <a:srgbClr val="7A6F68"/>
-                </a:solidFill>
-                <a:latin typeface="Calibri" pitchFamily="34" charset="0"/>
-                <a:ea typeface="Calibri" pitchFamily="34" charset="-122"/>
-                <a:cs typeface="Calibri" pitchFamily="34" charset="-120"/>
-              </a:rPr>
-              <a:t>Recopilación, limpieza e ingeniería de características</a:t>
-            </a:r>
-            <a:endParaRPr lang="en-US" sz="1150" dirty="0"/>
           </a:p>
         </p:txBody>
       </p:sp>
@@ -18776,7 +18502,7 @@
         </p:nvSpPr>
         <p:spPr>
           <a:xfrm>
-            <a:off x="1325880" y="2916936"/>
+            <a:off x="1325880" y="3040380"/>
             <a:ext cx="7772400" cy="365760"/>
           </a:xfrm>
           <a:prstGeom prst="rect">
@@ -18804,45 +18530,6 @@
               <a:t>Modelización y resultados</a:t>
             </a:r>
             <a:endParaRPr lang="en-US" sz="1650" dirty="0"/>
-          </a:p>
-        </p:txBody>
-      </p:sp>
-      <p:sp>
-        <p:nvSpPr>
-          <p:cNvPr id="18" name="Text 16"/>
-          <p:cNvSpPr/>
-          <p:nvPr/>
-        </p:nvSpPr>
-        <p:spPr>
-          <a:xfrm>
-            <a:off x="1325880" y="3264408"/>
-            <a:ext cx="8686800" cy="320040"/>
-          </a:xfrm>
-          <a:prstGeom prst="rect">
-            <a:avLst/>
-          </a:prstGeom>
-          <a:noFill/>
-          <a:ln/>
-        </p:spPr>
-        <p:txBody>
-          <a:bodyPr wrap="square" lIns="0" tIns="0" rIns="0" bIns="0" rtlCol="0" anchor="ctr"/>
-          <a:lstStyle/>
-          <a:p>
-            <a:pPr marL="0" indent="0">
-              <a:buNone/>
-            </a:pPr>
-            <a:r>
-              <a:rPr lang="en-US" sz="1150" dirty="0">
-                <a:solidFill>
-                  <a:srgbClr val="7A6F68"/>
-                </a:solidFill>
-                <a:latin typeface="Calibri" pitchFamily="34" charset="0"/>
-                <a:ea typeface="Calibri" pitchFamily="34" charset="-122"/>
-                <a:cs typeface="Calibri" pitchFamily="34" charset="-120"/>
-              </a:rPr>
-              <a:t>Cuatro modelos de regresión y su evaluación</a:t>
-            </a:r>
-            <a:endParaRPr lang="en-US" sz="1150" dirty="0"/>
           </a:p>
         </p:txBody>
       </p:sp>
@@ -18920,7 +18607,7 @@
         </p:nvSpPr>
         <p:spPr>
           <a:xfrm>
-            <a:off x="1325880" y="3694176"/>
+            <a:off x="1325880" y="3817620"/>
             <a:ext cx="7772400" cy="365760"/>
           </a:xfrm>
           <a:prstGeom prst="rect">
@@ -18948,45 +18635,6 @@
               <a:t>Categorización de chollos</a:t>
             </a:r>
             <a:endParaRPr lang="en-US" sz="1650" dirty="0"/>
-          </a:p>
-        </p:txBody>
-      </p:sp>
-      <p:sp>
-        <p:nvSpPr>
-          <p:cNvPr id="22" name="Text 20"/>
-          <p:cNvSpPr/>
-          <p:nvPr/>
-        </p:nvSpPr>
-        <p:spPr>
-          <a:xfrm>
-            <a:off x="1325880" y="4041648"/>
-            <a:ext cx="8686800" cy="320040"/>
-          </a:xfrm>
-          <a:prstGeom prst="rect">
-            <a:avLst/>
-          </a:prstGeom>
-          <a:noFill/>
-          <a:ln/>
-        </p:spPr>
-        <p:txBody>
-          <a:bodyPr wrap="square" lIns="0" tIns="0" rIns="0" bIns="0" rtlCol="0" anchor="ctr"/>
-          <a:lstStyle/>
-          <a:p>
-            <a:pPr marL="0" indent="0">
-              <a:buNone/>
-            </a:pPr>
-            <a:r>
-              <a:rPr lang="en-US" sz="1150" dirty="0">
-                <a:solidFill>
-                  <a:srgbClr val="7A6F68"/>
-                </a:solidFill>
-                <a:latin typeface="Calibri" pitchFamily="34" charset="0"/>
-                <a:ea typeface="Calibri" pitchFamily="34" charset="-122"/>
-                <a:cs typeface="Calibri" pitchFamily="34" charset="-120"/>
-              </a:rPr>
-              <a:t>Regla determinista y distribución obtenida</a:t>
-            </a:r>
-            <a:endParaRPr lang="en-US" sz="1150" dirty="0"/>
           </a:p>
         </p:txBody>
       </p:sp>
@@ -19064,7 +18712,7 @@
         </p:nvSpPr>
         <p:spPr>
           <a:xfrm>
-            <a:off x="1325880" y="4471416"/>
+            <a:off x="1325880" y="4594860"/>
             <a:ext cx="7772400" cy="365760"/>
           </a:xfrm>
           <a:prstGeom prst="rect">
@@ -19092,45 +18740,6 @@
               <a:t>Aplicación web</a:t>
             </a:r>
             <a:endParaRPr lang="en-US" sz="1650" dirty="0"/>
-          </a:p>
-        </p:txBody>
-      </p:sp>
-      <p:sp>
-        <p:nvSpPr>
-          <p:cNvPr id="26" name="Text 24"/>
-          <p:cNvSpPr/>
-          <p:nvPr/>
-        </p:nvSpPr>
-        <p:spPr>
-          <a:xfrm>
-            <a:off x="1325880" y="4818888"/>
-            <a:ext cx="8686800" cy="320040"/>
-          </a:xfrm>
-          <a:prstGeom prst="rect">
-            <a:avLst/>
-          </a:prstGeom>
-          <a:noFill/>
-          <a:ln/>
-        </p:spPr>
-        <p:txBody>
-          <a:bodyPr wrap="square" lIns="0" tIns="0" rIns="0" bIns="0" rtlCol="0" anchor="ctr"/>
-          <a:lstStyle/>
-          <a:p>
-            <a:pPr marL="0" indent="0">
-              <a:buNone/>
-            </a:pPr>
-            <a:r>
-              <a:rPr lang="en-US" sz="1150" dirty="0">
-                <a:solidFill>
-                  <a:srgbClr val="7A6F68"/>
-                </a:solidFill>
-                <a:latin typeface="Calibri" pitchFamily="34" charset="0"/>
-                <a:ea typeface="Calibri" pitchFamily="34" charset="-122"/>
-                <a:cs typeface="Calibri" pitchFamily="34" charset="-120"/>
-              </a:rPr>
-              <a:t>Arquitectura, flujo de uso y despliegue</a:t>
-            </a:r>
-            <a:endParaRPr lang="en-US" sz="1150" dirty="0"/>
           </a:p>
         </p:txBody>
       </p:sp>
@@ -19208,7 +18817,7 @@
         </p:nvSpPr>
         <p:spPr>
           <a:xfrm>
-            <a:off x="1325880" y="5248656"/>
+            <a:off x="1316736" y="5372100"/>
             <a:ext cx="7772400" cy="365760"/>
           </a:xfrm>
           <a:prstGeom prst="rect">
@@ -19236,45 +18845,6 @@
               <a:t>Conclusiones y trabajo futuro</a:t>
             </a:r>
             <a:endParaRPr lang="en-US" sz="1650" dirty="0"/>
-          </a:p>
-        </p:txBody>
-      </p:sp>
-      <p:sp>
-        <p:nvSpPr>
-          <p:cNvPr id="30" name="Text 28"/>
-          <p:cNvSpPr/>
-          <p:nvPr/>
-        </p:nvSpPr>
-        <p:spPr>
-          <a:xfrm>
-            <a:off x="1325880" y="5596128"/>
-            <a:ext cx="8686800" cy="320040"/>
-          </a:xfrm>
-          <a:prstGeom prst="rect">
-            <a:avLst/>
-          </a:prstGeom>
-          <a:noFill/>
-          <a:ln/>
-        </p:spPr>
-        <p:txBody>
-          <a:bodyPr wrap="square" lIns="0" tIns="0" rIns="0" bIns="0" rtlCol="0" anchor="ctr"/>
-          <a:lstStyle/>
-          <a:p>
-            <a:pPr marL="0" indent="0">
-              <a:buNone/>
-            </a:pPr>
-            <a:r>
-              <a:rPr lang="en-US" sz="1150" dirty="0">
-                <a:solidFill>
-                  <a:srgbClr val="7A6F68"/>
-                </a:solidFill>
-                <a:latin typeface="Calibri" pitchFamily="34" charset="0"/>
-                <a:ea typeface="Calibri" pitchFamily="34" charset="-122"/>
-                <a:cs typeface="Calibri" pitchFamily="34" charset="-120"/>
-              </a:rPr>
-              <a:t>Aportaciones principales y líneas de continuación</a:t>
-            </a:r>
-            <a:endParaRPr lang="en-US" sz="1150" dirty="0"/>
           </a:p>
         </p:txBody>
       </p:sp>
@@ -22095,7 +21665,84 @@
                 <a:ea typeface="Calibri" pitchFamily="34" charset="-122"/>
                 <a:cs typeface="Calibri" pitchFamily="34" charset="-120"/>
               </a:rPr>
-              <a:t>El precio de un alojamiento no es aleatorio</a:t>
+              <a:t>El </a:t>
+            </a:r>
+            <a:r>
+              <a:rPr lang="en-US" sz="1450" b="1" dirty="0" err="1">
+                <a:solidFill>
+                  <a:srgbClr val="2B2320"/>
+                </a:solidFill>
+                <a:latin typeface="Calibri" pitchFamily="34" charset="0"/>
+                <a:ea typeface="Calibri" pitchFamily="34" charset="-122"/>
+                <a:cs typeface="Calibri" pitchFamily="34" charset="-120"/>
+              </a:rPr>
+              <a:t>precio</a:t>
+            </a:r>
+            <a:r>
+              <a:rPr lang="en-US" sz="1450" b="1" dirty="0">
+                <a:solidFill>
+                  <a:srgbClr val="2B2320"/>
+                </a:solidFill>
+                <a:latin typeface="Calibri" pitchFamily="34" charset="0"/>
+                <a:ea typeface="Calibri" pitchFamily="34" charset="-122"/>
+                <a:cs typeface="Calibri" pitchFamily="34" charset="-120"/>
+              </a:rPr>
+              <a:t> </a:t>
+            </a:r>
+            <a:r>
+              <a:rPr lang="en-US" sz="1450" b="1" dirty="0" err="1">
+                <a:solidFill>
+                  <a:srgbClr val="2B2320"/>
+                </a:solidFill>
+                <a:latin typeface="Calibri" pitchFamily="34" charset="0"/>
+                <a:ea typeface="Calibri" pitchFamily="34" charset="-122"/>
+                <a:cs typeface="Calibri" pitchFamily="34" charset="-120"/>
+              </a:rPr>
+              <a:t>presenta</a:t>
+            </a:r>
+            <a:r>
+              <a:rPr lang="en-US" sz="1450" b="1" dirty="0">
+                <a:solidFill>
+                  <a:srgbClr val="2B2320"/>
+                </a:solidFill>
+                <a:latin typeface="Calibri" pitchFamily="34" charset="0"/>
+                <a:ea typeface="Calibri" pitchFamily="34" charset="-122"/>
+                <a:cs typeface="Calibri" pitchFamily="34" charset="-120"/>
+              </a:rPr>
+              <a:t> </a:t>
+            </a:r>
+            <a:r>
+              <a:rPr lang="en-US" sz="1450" b="1" dirty="0" err="1">
+                <a:solidFill>
+                  <a:srgbClr val="2B2320"/>
+                </a:solidFill>
+                <a:latin typeface="Calibri" pitchFamily="34" charset="0"/>
+                <a:ea typeface="Calibri" pitchFamily="34" charset="-122"/>
+                <a:cs typeface="Calibri" pitchFamily="34" charset="-120"/>
+              </a:rPr>
+              <a:t>patrones</a:t>
+            </a:r>
+            <a:r>
+              <a:rPr lang="en-US" sz="1450" b="1" dirty="0">
+                <a:solidFill>
+                  <a:srgbClr val="2B2320"/>
+                </a:solidFill>
+                <a:latin typeface="Calibri" pitchFamily="34" charset="0"/>
+                <a:ea typeface="Calibri" pitchFamily="34" charset="-122"/>
+                <a:cs typeface="Calibri" pitchFamily="34" charset="-120"/>
+              </a:rPr>
+              <a:t> </a:t>
+            </a:r>
+            <a:r>
+              <a:rPr lang="en-US" sz="1450" b="1" dirty="0" err="1">
+                <a:solidFill>
+                  <a:srgbClr val="2B2320"/>
+                </a:solidFill>
+                <a:latin typeface="Calibri" pitchFamily="34" charset="0"/>
+                <a:ea typeface="Calibri" pitchFamily="34" charset="-122"/>
+                <a:cs typeface="Calibri" pitchFamily="34" charset="-120"/>
+              </a:rPr>
+              <a:t>predictivos</a:t>
             </a:r>
             <a:endParaRPr lang="en-US" sz="1450" dirty="0"/>
           </a:p>
@@ -22883,7 +22530,7 @@
         </p:nvSpPr>
         <p:spPr>
           <a:xfrm>
-            <a:off x="548640" y="1508760"/>
+            <a:off x="548640" y="2276856"/>
             <a:ext cx="502920" cy="502920"/>
           </a:xfrm>
           <a:prstGeom prst="ellipse">
@@ -22918,7 +22565,7 @@
         </p:blipFill>
         <p:spPr>
           <a:xfrm>
-            <a:off x="659282" y="1619402"/>
+            <a:off x="659282" y="2387498"/>
             <a:ext cx="281635" cy="281635"/>
           </a:xfrm>
           <a:prstGeom prst="rect">
@@ -22934,7 +22581,7 @@
         </p:nvSpPr>
         <p:spPr>
           <a:xfrm>
-            <a:off x="1280160" y="1481328"/>
+            <a:off x="1280160" y="2249424"/>
             <a:ext cx="10360152" cy="292608"/>
           </a:xfrm>
           <a:prstGeom prst="rect">
@@ -22973,7 +22620,7 @@
         </p:nvSpPr>
         <p:spPr>
           <a:xfrm>
-            <a:off x="1280160" y="1764792"/>
+            <a:off x="1280160" y="2532888"/>
             <a:ext cx="10360152" cy="457200"/>
           </a:xfrm>
           <a:prstGeom prst="rect">
@@ -22992,7 +22639,10 @@
             <a:r>
               <a:rPr lang="en-US" sz="1100" dirty="0">
                 <a:solidFill>
-                  <a:srgbClr val="7A6F68"/>
+                  <a:schemeClr val="tx1">
+                    <a:lumMod val="50000"/>
+                    <a:lumOff val="50000"/>
+                  </a:schemeClr>
                 </a:solidFill>
                 <a:latin typeface="Calibri" pitchFamily="34" charset="0"/>
                 <a:ea typeface="Calibri" pitchFamily="34" charset="-122"/>
@@ -23000,7 +22650,14 @@
               </a:rPr>
               <a:t>Extender la cobertura a otras comunidades autónomas u otras OTA</a:t>
             </a:r>
-            <a:endParaRPr lang="en-US" sz="1100" dirty="0"/>
+            <a:endParaRPr lang="en-US" sz="1100" dirty="0">
+              <a:solidFill>
+                <a:schemeClr val="tx1">
+                  <a:lumMod val="50000"/>
+                  <a:lumOff val="50000"/>
+                </a:schemeClr>
+              </a:solidFill>
+            </a:endParaRPr>
           </a:p>
         </p:txBody>
       </p:sp>
@@ -23012,7 +22669,7 @@
         </p:nvSpPr>
         <p:spPr>
           <a:xfrm>
-            <a:off x="548640" y="2423160"/>
+            <a:off x="548640" y="3191256"/>
             <a:ext cx="502920" cy="502920"/>
           </a:xfrm>
           <a:prstGeom prst="ellipse">
@@ -23047,7 +22704,7 @@
         </p:blipFill>
         <p:spPr>
           <a:xfrm>
-            <a:off x="659282" y="2533802"/>
+            <a:off x="659282" y="3301898"/>
             <a:ext cx="281635" cy="281635"/>
           </a:xfrm>
           <a:prstGeom prst="rect">
@@ -23063,7 +22720,7 @@
         </p:nvSpPr>
         <p:spPr>
           <a:xfrm>
-            <a:off x="1280160" y="2395728"/>
+            <a:off x="1280160" y="3163824"/>
             <a:ext cx="10360152" cy="292608"/>
           </a:xfrm>
           <a:prstGeom prst="rect">
@@ -23102,7 +22759,7 @@
         </p:nvSpPr>
         <p:spPr>
           <a:xfrm>
-            <a:off x="1280160" y="2679192"/>
+            <a:off x="1280160" y="3447288"/>
             <a:ext cx="10360152" cy="457200"/>
           </a:xfrm>
           <a:prstGeom prst="rect">
@@ -23141,7 +22798,7 @@
         </p:nvSpPr>
         <p:spPr>
           <a:xfrm>
-            <a:off x="548640" y="3337560"/>
+            <a:off x="548640" y="4105656"/>
             <a:ext cx="502920" cy="502920"/>
           </a:xfrm>
           <a:prstGeom prst="ellipse">
@@ -23176,7 +22833,7 @@
         </p:blipFill>
         <p:spPr>
           <a:xfrm>
-            <a:off x="659282" y="3448202"/>
+            <a:off x="659282" y="4216298"/>
             <a:ext cx="281635" cy="281635"/>
           </a:xfrm>
           <a:prstGeom prst="rect">
@@ -23192,7 +22849,7 @@
         </p:nvSpPr>
         <p:spPr>
           <a:xfrm>
-            <a:off x="1280160" y="3310128"/>
+            <a:off x="1280160" y="4078224"/>
             <a:ext cx="10360152" cy="292608"/>
           </a:xfrm>
           <a:prstGeom prst="rect">
@@ -23231,7 +22888,7 @@
         </p:nvSpPr>
         <p:spPr>
           <a:xfrm>
-            <a:off x="1280160" y="3593592"/>
+            <a:off x="1280160" y="4361688"/>
             <a:ext cx="10360152" cy="457200"/>
           </a:xfrm>
           <a:prstGeom prst="rect">
@@ -23270,7 +22927,7 @@
         </p:nvSpPr>
         <p:spPr>
           <a:xfrm>
-            <a:off x="548640" y="4251960"/>
+            <a:off x="548640" y="5020056"/>
             <a:ext cx="502920" cy="502920"/>
           </a:xfrm>
           <a:prstGeom prst="ellipse">
@@ -23305,7 +22962,7 @@
         </p:blipFill>
         <p:spPr>
           <a:xfrm>
-            <a:off x="659282" y="4362602"/>
+            <a:off x="659282" y="5130698"/>
             <a:ext cx="281635" cy="281635"/>
           </a:xfrm>
           <a:prstGeom prst="rect">
@@ -23321,7 +22978,7 @@
         </p:nvSpPr>
         <p:spPr>
           <a:xfrm>
-            <a:off x="1280160" y="4224528"/>
+            <a:off x="1280160" y="4992624"/>
             <a:ext cx="10360152" cy="292608"/>
           </a:xfrm>
           <a:prstGeom prst="rect">
@@ -23360,7 +23017,7 @@
         </p:nvSpPr>
         <p:spPr>
           <a:xfrm>
-            <a:off x="1280160" y="4507992"/>
+            <a:off x="1280160" y="5276088"/>
             <a:ext cx="10360152" cy="457200"/>
           </a:xfrm>
           <a:prstGeom prst="rect">
@@ -23399,7 +23056,7 @@
         </p:nvSpPr>
         <p:spPr>
           <a:xfrm>
-            <a:off x="548640" y="5166360"/>
+            <a:off x="548640" y="1350454"/>
             <a:ext cx="502920" cy="502920"/>
           </a:xfrm>
           <a:prstGeom prst="ellipse">
@@ -23434,7 +23091,7 @@
         </p:blipFill>
         <p:spPr>
           <a:xfrm>
-            <a:off x="659282" y="5277002"/>
+            <a:off x="659282" y="1461096"/>
             <a:ext cx="281635" cy="281635"/>
           </a:xfrm>
           <a:prstGeom prst="rect">
@@ -23450,7 +23107,7 @@
         </p:nvSpPr>
         <p:spPr>
           <a:xfrm>
-            <a:off x="1280160" y="5138928"/>
+            <a:off x="1280160" y="1323022"/>
             <a:ext cx="10360152" cy="292608"/>
           </a:xfrm>
           <a:prstGeom prst="rect">
@@ -23467,6 +23124,17 @@
               <a:buNone/>
             </a:pPr>
             <a:r>
+              <a:rPr lang="en-US" sz="1450" b="1" dirty="0" err="1">
+                <a:solidFill>
+                  <a:srgbClr val="2B2320"/>
+                </a:solidFill>
+                <a:latin typeface="Calibri" pitchFamily="34" charset="0"/>
+                <a:ea typeface="Calibri" pitchFamily="34" charset="-122"/>
+                <a:cs typeface="Calibri" pitchFamily="34" charset="-120"/>
+              </a:rPr>
+              <a:t>Codificación</a:t>
+            </a:r>
+            <a:r>
               <a:rPr lang="en-US" sz="1450" b="1" dirty="0">
                 <a:solidFill>
                   <a:srgbClr val="2B2320"/>
@@ -23475,7 +23143,73 @@
                 <a:ea typeface="Calibri" pitchFamily="34" charset="-122"/>
                 <a:cs typeface="Calibri" pitchFamily="34" charset="-120"/>
               </a:rPr>
-              <a:t>Aprendizaje no supervisado complementario</a:t>
+              <a:t> de </a:t>
+            </a:r>
+            <a:r>
+              <a:rPr lang="en-US" sz="1450" b="1" i="1" dirty="0" err="1">
+                <a:solidFill>
+                  <a:srgbClr val="2B2320"/>
+                </a:solidFill>
+                <a:latin typeface="Calibri" pitchFamily="34" charset="0"/>
+                <a:ea typeface="Calibri" pitchFamily="34" charset="-122"/>
+                <a:cs typeface="Calibri" pitchFamily="34" charset="-120"/>
+              </a:rPr>
+              <a:t>localidad</a:t>
+            </a:r>
+            <a:r>
+              <a:rPr lang="en-US" sz="1450" b="1" dirty="0">
+                <a:solidFill>
+                  <a:srgbClr val="2B2320"/>
+                </a:solidFill>
+                <a:latin typeface="Calibri" pitchFamily="34" charset="0"/>
+                <a:ea typeface="Calibri" pitchFamily="34" charset="-122"/>
+                <a:cs typeface="Calibri" pitchFamily="34" charset="-120"/>
+              </a:rPr>
+              <a:t> y </a:t>
+            </a:r>
+            <a:r>
+              <a:rPr lang="en-US" sz="1450" b="1" i="1" dirty="0">
+                <a:solidFill>
+                  <a:srgbClr val="2B2320"/>
+                </a:solidFill>
+                <a:latin typeface="Calibri" pitchFamily="34" charset="0"/>
+                <a:ea typeface="Calibri" pitchFamily="34" charset="-122"/>
+                <a:cs typeface="Calibri" pitchFamily="34" charset="-120"/>
+              </a:rPr>
+              <a:t>provincial</a:t>
+            </a:r>
+            <a:r>
+              <a:rPr lang="en-US" sz="1450" b="1" dirty="0">
+                <a:solidFill>
+                  <a:srgbClr val="2B2320"/>
+                </a:solidFill>
+                <a:latin typeface="Calibri" pitchFamily="34" charset="0"/>
+                <a:ea typeface="Calibri" pitchFamily="34" charset="-122"/>
+                <a:cs typeface="Calibri" pitchFamily="34" charset="-120"/>
+              </a:rPr>
+              <a:t> </a:t>
+            </a:r>
+            <a:r>
+              <a:rPr lang="en-US" sz="1450" b="1" dirty="0" err="1">
+                <a:solidFill>
+                  <a:srgbClr val="2B2320"/>
+                </a:solidFill>
+                <a:latin typeface="Calibri" pitchFamily="34" charset="0"/>
+                <a:ea typeface="Calibri" pitchFamily="34" charset="-122"/>
+                <a:cs typeface="Calibri" pitchFamily="34" charset="-120"/>
+              </a:rPr>
+              <a:t>como</a:t>
+            </a:r>
+            <a:r>
+              <a:rPr lang="en-US" sz="1450" b="1" dirty="0">
+                <a:solidFill>
+                  <a:srgbClr val="2B2320"/>
+                </a:solidFill>
+                <a:latin typeface="Calibri" pitchFamily="34" charset="0"/>
+                <a:ea typeface="Calibri" pitchFamily="34" charset="-122"/>
+                <a:cs typeface="Calibri" pitchFamily="34" charset="-120"/>
+              </a:rPr>
+              <a:t> “one-hot-encoding”</a:t>
             </a:r>
             <a:endParaRPr lang="en-US" sz="1450" dirty="0"/>
           </a:p>
@@ -23489,7 +23223,7 @@
         </p:nvSpPr>
         <p:spPr>
           <a:xfrm>
-            <a:off x="1280160" y="5422392"/>
+            <a:off x="1280160" y="1606486"/>
             <a:ext cx="10360152" cy="457200"/>
           </a:xfrm>
           <a:prstGeom prst="rect">
@@ -23506,17 +23240,156 @@
               <a:buNone/>
             </a:pPr>
             <a:r>
+              <a:rPr lang="en-US" sz="1100" dirty="0" err="1">
+                <a:solidFill>
+                  <a:schemeClr val="tx1">
+                    <a:lumMod val="50000"/>
+                    <a:lumOff val="50000"/>
+                  </a:schemeClr>
+                </a:solidFill>
+              </a:rPr>
+              <a:t>Que</a:t>
+            </a:r>
+            <a:r>
               <a:rPr lang="en-US" sz="1100" dirty="0">
                 <a:solidFill>
-                  <a:srgbClr val="7A6F68"/>
-                </a:solidFill>
-                <a:latin typeface="Calibri" pitchFamily="34" charset="0"/>
-                <a:ea typeface="Calibri" pitchFamily="34" charset="-122"/>
-                <a:cs typeface="Calibri" pitchFamily="34" charset="-120"/>
-              </a:rPr>
-              <a:t>Isolation Forest o Local Outlier Factor para categorías con pocos datos</a:t>
-            </a:r>
-            <a:endParaRPr lang="en-US" sz="1100" dirty="0"/>
+                  <a:schemeClr val="tx1">
+                    <a:lumMod val="50000"/>
+                    <a:lumOff val="50000"/>
+                  </a:schemeClr>
+                </a:solidFill>
+              </a:rPr>
+              <a:t> el </a:t>
+            </a:r>
+            <a:r>
+              <a:rPr lang="en-US" sz="1100" dirty="0" err="1">
+                <a:solidFill>
+                  <a:schemeClr val="tx1">
+                    <a:lumMod val="50000"/>
+                    <a:lumOff val="50000"/>
+                  </a:schemeClr>
+                </a:solidFill>
+              </a:rPr>
+              <a:t>modelo</a:t>
+            </a:r>
+            <a:r>
+              <a:rPr lang="en-US" sz="1100" dirty="0">
+                <a:solidFill>
+                  <a:schemeClr val="tx1">
+                    <a:lumMod val="50000"/>
+                    <a:lumOff val="50000"/>
+                  </a:schemeClr>
+                </a:solidFill>
+              </a:rPr>
+              <a:t> no </a:t>
+            </a:r>
+            <a:r>
+              <a:rPr lang="en-US" sz="1100" dirty="0" err="1">
+                <a:solidFill>
+                  <a:schemeClr val="tx1">
+                    <a:lumMod val="50000"/>
+                    <a:lumOff val="50000"/>
+                  </a:schemeClr>
+                </a:solidFill>
+              </a:rPr>
+              <a:t>pueda</a:t>
+            </a:r>
+            <a:r>
+              <a:rPr lang="en-US" sz="1100" dirty="0">
+                <a:solidFill>
+                  <a:schemeClr val="tx1">
+                    <a:lumMod val="50000"/>
+                    <a:lumOff val="50000"/>
+                  </a:schemeClr>
+                </a:solidFill>
+              </a:rPr>
+              <a:t> </a:t>
+            </a:r>
+            <a:r>
+              <a:rPr lang="en-US" sz="1100" dirty="0" err="1">
+                <a:solidFill>
+                  <a:schemeClr val="tx1">
+                    <a:lumMod val="50000"/>
+                    <a:lumOff val="50000"/>
+                  </a:schemeClr>
+                </a:solidFill>
+              </a:rPr>
+              <a:t>aprender</a:t>
+            </a:r>
+            <a:r>
+              <a:rPr lang="en-US" sz="1100" dirty="0">
+                <a:solidFill>
+                  <a:schemeClr val="tx1">
+                    <a:lumMod val="50000"/>
+                    <a:lumOff val="50000"/>
+                  </a:schemeClr>
+                </a:solidFill>
+              </a:rPr>
+              <a:t> </a:t>
+            </a:r>
+            <a:r>
+              <a:rPr lang="en-US" sz="1100" dirty="0" err="1">
+                <a:solidFill>
+                  <a:schemeClr val="tx1">
+                    <a:lumMod val="50000"/>
+                    <a:lumOff val="50000"/>
+                  </a:schemeClr>
+                </a:solidFill>
+              </a:rPr>
+              <a:t>patrones</a:t>
+            </a:r>
+            <a:r>
+              <a:rPr lang="en-US" sz="1100" dirty="0">
+                <a:solidFill>
+                  <a:schemeClr val="tx1">
+                    <a:lumMod val="50000"/>
+                    <a:lumOff val="50000"/>
+                  </a:schemeClr>
+                </a:solidFill>
+              </a:rPr>
+              <a:t> a </a:t>
+            </a:r>
+            <a:r>
+              <a:rPr lang="en-US" sz="1100" dirty="0" err="1">
+                <a:solidFill>
+                  <a:schemeClr val="tx1">
+                    <a:lumMod val="50000"/>
+                    <a:lumOff val="50000"/>
+                  </a:schemeClr>
+                </a:solidFill>
+              </a:rPr>
+              <a:t>través</a:t>
+            </a:r>
+            <a:r>
+              <a:rPr lang="en-US" sz="1100" dirty="0">
+                <a:solidFill>
+                  <a:schemeClr val="tx1">
+                    <a:lumMod val="50000"/>
+                    <a:lumOff val="50000"/>
+                  </a:schemeClr>
+                </a:solidFill>
+              </a:rPr>
+              <a:t> del </a:t>
+            </a:r>
+            <a:r>
+              <a:rPr lang="en-US" sz="1100" dirty="0" err="1">
+                <a:solidFill>
+                  <a:schemeClr val="tx1">
+                    <a:lumMod val="50000"/>
+                    <a:lumOff val="50000"/>
+                  </a:schemeClr>
+                </a:solidFill>
+              </a:rPr>
+              <a:t>orden</a:t>
+            </a:r>
+            <a:endParaRPr lang="en-US" sz="1100" dirty="0">
+              <a:solidFill>
+                <a:schemeClr val="tx1">
+                  <a:lumMod val="50000"/>
+                  <a:lumOff val="50000"/>
+                </a:schemeClr>
+              </a:solidFill>
+            </a:endParaRPr>
           </a:p>
         </p:txBody>
       </p:sp>
@@ -27007,7 +26880,7 @@
         <p:spPr>
           <a:xfrm>
             <a:off x="6245352" y="1463040"/>
-            <a:ext cx="5394960" cy="3447288"/>
+            <a:ext cx="5394960" cy="3695814"/>
           </a:xfrm>
           <a:prstGeom prst="roundRect">
             <a:avLst>
@@ -27133,7 +27006,7 @@
         <p:spPr>
           <a:xfrm>
             <a:off x="6519672" y="2423160"/>
-            <a:ext cx="4892040" cy="3474720"/>
+            <a:ext cx="4892040" cy="2514600"/>
           </a:xfrm>
           <a:prstGeom prst="rect">
             <a:avLst/>
@@ -27652,6 +27525,17 @@
               <a:buChar char="•"/>
             </a:pPr>
             <a:r>
+              <a:rPr lang="en-US" sz="1300" dirty="0" err="1">
+                <a:solidFill>
+                  <a:srgbClr val="2B2320"/>
+                </a:solidFill>
+                <a:latin typeface="Calibri" pitchFamily="34" charset="0"/>
+                <a:ea typeface="Calibri" pitchFamily="34" charset="-122"/>
+                <a:cs typeface="Calibri" pitchFamily="34" charset="-120"/>
+              </a:rPr>
+              <a:t>Extracción</a:t>
+            </a:r>
+            <a:r>
               <a:rPr lang="en-US" sz="1300" dirty="0">
                 <a:solidFill>
                   <a:srgbClr val="2B2320"/>
@@ -27660,7 +27544,7 @@
                 <a:ea typeface="Calibri" pitchFamily="34" charset="-122"/>
                 <a:cs typeface="Calibri" pitchFamily="34" charset="-120"/>
               </a:rPr>
-              <a:t>Por </a:t>
+              <a:t> de </a:t>
             </a:r>
             <a:r>
               <a:rPr lang="en-US" sz="1300" dirty="0" err="1">
@@ -27671,7 +27555,7 @@
                 <a:ea typeface="Calibri" pitchFamily="34" charset="-122"/>
                 <a:cs typeface="Calibri" pitchFamily="34" charset="-120"/>
               </a:rPr>
-              <a:t>prudencia</a:t>
+              <a:t>datos</a:t>
             </a:r>
             <a:r>
               <a:rPr lang="en-US" sz="1300" dirty="0">
@@ -27682,7 +27566,7 @@
                 <a:ea typeface="Calibri" pitchFamily="34" charset="-122"/>
                 <a:cs typeface="Calibri" pitchFamily="34" charset="-120"/>
               </a:rPr>
-              <a:t>, la plataforma de </a:t>
+              <a:t> </a:t>
             </a:r>
             <a:r>
               <a:rPr lang="en-US" sz="1300" dirty="0" err="1">
@@ -27693,7 +27577,7 @@
                 <a:ea typeface="Calibri" pitchFamily="34" charset="-122"/>
                 <a:cs typeface="Calibri" pitchFamily="34" charset="-120"/>
               </a:rPr>
-              <a:t>origen</a:t>
+              <a:t>realizada</a:t>
             </a:r>
             <a:r>
               <a:rPr lang="en-US" sz="1300" dirty="0">
@@ -27704,7 +27588,7 @@
                 <a:ea typeface="Calibri" pitchFamily="34" charset="-122"/>
                 <a:cs typeface="Calibri" pitchFamily="34" charset="-120"/>
               </a:rPr>
-              <a:t> de </a:t>
+              <a:t> solo a </a:t>
             </a:r>
             <a:r>
               <a:rPr lang="en-US" sz="1300" dirty="0" err="1">
@@ -27715,7 +27599,7 @@
                 <a:ea typeface="Calibri" pitchFamily="34" charset="-122"/>
                 <a:cs typeface="Calibri" pitchFamily="34" charset="-120"/>
               </a:rPr>
-              <a:t>los</a:t>
+              <a:t>través</a:t>
             </a:r>
             <a:r>
               <a:rPr lang="en-US" sz="1300" dirty="0">
@@ -27726,6 +27610,109 @@
                 <a:ea typeface="Calibri" pitchFamily="34" charset="-122"/>
                 <a:cs typeface="Calibri" pitchFamily="34" charset="-120"/>
               </a:rPr>
+              <a:t> de Booking.com.</a:t>
+            </a:r>
+          </a:p>
+          <a:p>
+            <a:pPr marL="342900" indent="-342900">
+              <a:lnSpc>
+                <a:spcPct val="115000"/>
+              </a:lnSpc>
+              <a:buSzPct val="100000"/>
+              <a:buChar char="•"/>
+            </a:pPr>
+            <a:endParaRPr lang="en-US" sz="1300" dirty="0">
+              <a:solidFill>
+                <a:srgbClr val="2B2320"/>
+              </a:solidFill>
+              <a:latin typeface="Calibri" pitchFamily="34" charset="0"/>
+              <a:ea typeface="Calibri" pitchFamily="34" charset="-122"/>
+              <a:cs typeface="Calibri" pitchFamily="34" charset="-120"/>
+            </a:endParaRPr>
+          </a:p>
+          <a:p>
+            <a:pPr marL="342900" indent="-342900">
+              <a:lnSpc>
+                <a:spcPct val="115000"/>
+              </a:lnSpc>
+              <a:buSzPct val="100000"/>
+              <a:buChar char="•"/>
+            </a:pPr>
+            <a:r>
+              <a:rPr lang="en-US" sz="1300" dirty="0">
+                <a:solidFill>
+                  <a:srgbClr val="2B2320"/>
+                </a:solidFill>
+                <a:latin typeface="Calibri" pitchFamily="34" charset="0"/>
+                <a:ea typeface="Calibri" pitchFamily="34" charset="-122"/>
+                <a:cs typeface="Calibri" pitchFamily="34" charset="-120"/>
+              </a:rPr>
+              <a:t>Las variables </a:t>
+            </a:r>
+            <a:r>
+              <a:rPr lang="en-US" sz="1300" i="1" dirty="0" err="1">
+                <a:solidFill>
+                  <a:srgbClr val="2B2320"/>
+                </a:solidFill>
+                <a:latin typeface="Calibri" pitchFamily="34" charset="0"/>
+                <a:ea typeface="Calibri" pitchFamily="34" charset="-122"/>
+                <a:cs typeface="Calibri" pitchFamily="34" charset="-120"/>
+              </a:rPr>
+              <a:t>localidad</a:t>
+            </a:r>
+            <a:r>
+              <a:rPr lang="en-US" sz="1300" dirty="0">
+                <a:solidFill>
+                  <a:srgbClr val="2B2320"/>
+                </a:solidFill>
+                <a:latin typeface="Calibri" pitchFamily="34" charset="0"/>
+                <a:ea typeface="Calibri" pitchFamily="34" charset="-122"/>
+                <a:cs typeface="Calibri" pitchFamily="34" charset="-120"/>
+              </a:rPr>
+              <a:t> y </a:t>
+            </a:r>
+            <a:r>
+              <a:rPr lang="en-US" sz="1300" i="1" dirty="0" err="1">
+                <a:solidFill>
+                  <a:srgbClr val="2B2320"/>
+                </a:solidFill>
+                <a:latin typeface="Calibri" pitchFamily="34" charset="0"/>
+                <a:ea typeface="Calibri" pitchFamily="34" charset="-122"/>
+                <a:cs typeface="Calibri" pitchFamily="34" charset="-120"/>
+              </a:rPr>
+              <a:t>provincia</a:t>
+            </a:r>
+            <a:r>
+              <a:rPr lang="en-US" sz="1300" dirty="0">
+                <a:solidFill>
+                  <a:srgbClr val="2B2320"/>
+                </a:solidFill>
+                <a:latin typeface="Calibri" pitchFamily="34" charset="0"/>
+                <a:ea typeface="Calibri" pitchFamily="34" charset="-122"/>
+                <a:cs typeface="Calibri" pitchFamily="34" charset="-120"/>
+              </a:rPr>
+              <a:t> se </a:t>
+            </a:r>
+            <a:r>
+              <a:rPr lang="en-US" sz="1300" dirty="0" err="1">
+                <a:solidFill>
+                  <a:srgbClr val="2B2320"/>
+                </a:solidFill>
+                <a:latin typeface="Calibri" pitchFamily="34" charset="0"/>
+                <a:ea typeface="Calibri" pitchFamily="34" charset="-122"/>
+                <a:cs typeface="Calibri" pitchFamily="34" charset="-120"/>
+              </a:rPr>
+              <a:t>codifican</a:t>
+            </a:r>
+            <a:r>
+              <a:rPr lang="en-US" sz="1300" dirty="0">
+                <a:solidFill>
+                  <a:srgbClr val="2B2320"/>
+                </a:solidFill>
+                <a:latin typeface="Calibri" pitchFamily="34" charset="0"/>
+                <a:ea typeface="Calibri" pitchFamily="34" charset="-122"/>
+                <a:cs typeface="Calibri" pitchFamily="34" charset="-120"/>
+              </a:rPr>
               <a:t> </a:t>
             </a:r>
             <a:r>
@@ -27737,7 +27724,7 @@
                 <a:ea typeface="Calibri" pitchFamily="34" charset="-122"/>
                 <a:cs typeface="Calibri" pitchFamily="34" charset="-120"/>
               </a:rPr>
-              <a:t>datos</a:t>
+              <a:t>como</a:t>
             </a:r>
             <a:r>
               <a:rPr lang="en-US" sz="1300" dirty="0">
@@ -27748,7 +27735,7 @@
                 <a:ea typeface="Calibri" pitchFamily="34" charset="-122"/>
                 <a:cs typeface="Calibri" pitchFamily="34" charset="-120"/>
               </a:rPr>
-              <a:t> no se </a:t>
+              <a:t> </a:t>
             </a:r>
             <a:r>
               <a:rPr lang="en-US" sz="1300" dirty="0" err="1">
@@ -27759,7 +27746,7 @@
                 <a:ea typeface="Calibri" pitchFamily="34" charset="-122"/>
                 <a:cs typeface="Calibri" pitchFamily="34" charset="-120"/>
               </a:rPr>
-              <a:t>identifica</a:t>
+              <a:t>ordinales</a:t>
             </a:r>
             <a:r>
               <a:rPr lang="en-US" sz="1300" dirty="0">
@@ -27770,7 +27757,7 @@
                 <a:ea typeface="Calibri" pitchFamily="34" charset="-122"/>
                 <a:cs typeface="Calibri" pitchFamily="34" charset="-120"/>
               </a:rPr>
-              <a:t> </a:t>
+              <a:t> para </a:t>
             </a:r>
             <a:r>
               <a:rPr lang="en-US" sz="1300" dirty="0" err="1">
@@ -27781,7 +27768,7 @@
                 <a:ea typeface="Calibri" pitchFamily="34" charset="-122"/>
                 <a:cs typeface="Calibri" pitchFamily="34" charset="-120"/>
               </a:rPr>
-              <a:t>explícitamente</a:t>
+              <a:t>reducir</a:t>
             </a:r>
             <a:r>
               <a:rPr lang="en-US" sz="1300" dirty="0">
@@ -27792,7 +27779,7 @@
                 <a:ea typeface="Calibri" pitchFamily="34" charset="-122"/>
                 <a:cs typeface="Calibri" pitchFamily="34" charset="-120"/>
               </a:rPr>
-              <a:t> </a:t>
+              <a:t> la </a:t>
             </a:r>
             <a:r>
               <a:rPr lang="en-US" sz="1300" dirty="0" err="1">
@@ -27803,7 +27790,7 @@
                 <a:ea typeface="Calibri" pitchFamily="34" charset="-122"/>
                 <a:cs typeface="Calibri" pitchFamily="34" charset="-120"/>
               </a:rPr>
-              <a:t>en</a:t>
+              <a:t>dimensionalidad</a:t>
             </a:r>
             <a:r>
               <a:rPr lang="en-US" sz="1300" dirty="0">
@@ -27814,52 +27801,17 @@
                 <a:ea typeface="Calibri" pitchFamily="34" charset="-122"/>
                 <a:cs typeface="Calibri" pitchFamily="34" charset="-120"/>
               </a:rPr>
-              <a:t> la </a:t>
-            </a:r>
-            <a:r>
-              <a:rPr lang="en-US" sz="1300" dirty="0" err="1">
-                <a:solidFill>
-                  <a:srgbClr val="2B2320"/>
-                </a:solidFill>
-                <a:latin typeface="Calibri" pitchFamily="34" charset="0"/>
-                <a:ea typeface="Calibri" pitchFamily="34" charset="-122"/>
-                <a:cs typeface="Calibri" pitchFamily="34" charset="-120"/>
-              </a:rPr>
-              <a:t>memoria</a:t>
-            </a:r>
-            <a:r>
-              <a:rPr lang="en-US" sz="1300" dirty="0">
-                <a:solidFill>
-                  <a:srgbClr val="2B2320"/>
-                </a:solidFill>
-                <a:latin typeface="Calibri" pitchFamily="34" charset="0"/>
-                <a:ea typeface="Calibri" pitchFamily="34" charset="-122"/>
-                <a:cs typeface="Calibri" pitchFamily="34" charset="-120"/>
-              </a:rPr>
-              <a:t>. Se </a:t>
-            </a:r>
-            <a:r>
-              <a:rPr lang="en-US" sz="1300" dirty="0" err="1">
-                <a:solidFill>
-                  <a:srgbClr val="2B2320"/>
-                </a:solidFill>
-                <a:latin typeface="Calibri" pitchFamily="34" charset="0"/>
-                <a:ea typeface="Calibri" pitchFamily="34" charset="-122"/>
-                <a:cs typeface="Calibri" pitchFamily="34" charset="-120"/>
-              </a:rPr>
-              <a:t>trata</a:t>
-            </a:r>
-            <a:r>
-              <a:rPr lang="en-US" sz="1300" dirty="0">
-                <a:solidFill>
-                  <a:srgbClr val="2B2320"/>
-                </a:solidFill>
-                <a:latin typeface="Calibri" pitchFamily="34" charset="0"/>
-                <a:ea typeface="Calibri" pitchFamily="34" charset="-122"/>
-                <a:cs typeface="Calibri" pitchFamily="34" charset="-120"/>
-              </a:rPr>
-              <a:t> de Booking.com.</a:t>
-            </a:r>
+              <a:t>.</a:t>
+            </a:r>
+          </a:p>
+          <a:p>
+            <a:pPr marL="342900" indent="-342900">
+              <a:lnSpc>
+                <a:spcPct val="115000"/>
+              </a:lnSpc>
+              <a:buSzPct val="100000"/>
+              <a:buChar char="•"/>
+            </a:pPr>
             <a:endParaRPr lang="en-US" sz="1300" dirty="0"/>
           </a:p>
         </p:txBody>

</xml_diff>

<commit_message>
fix: Inconsistencia de nombres (árbol de regresión en vez de árbol de decisión) y 'provincia' en vez de 'provincial'
</commit_message>
<xml_diff>
--- a/TFG_Chollos/Presentacion_Defensa_TFG.pptx
+++ b/TFG_Chollos/Presentacion_Defensa_TFG.pptx
@@ -21151,7 +21151,29 @@
                 <a:ea typeface="Calibri" pitchFamily="34" charset="-122"/>
                 <a:cs typeface="Calibri" pitchFamily="34" charset="-120"/>
               </a:rPr>
-              <a:t>Pérdida mínima de rendimiento; el modelo podado sigue superando ampliamente al 2º mejor modelo (árbol de decisión, R² = 0,59).</a:t>
+              <a:t>Pérdida mínima de rendimiento; el modelo podado sigue superando ampliamente al 2º mejor modelo (árbol de </a:t>
+            </a:r>
+            <a:r>
+              <a:rPr lang="en-US" sz="1200" i="1" dirty="0" err="1">
+                <a:solidFill>
+                  <a:srgbClr val="7A6F68"/>
+                </a:solidFill>
+                <a:latin typeface="Calibri" pitchFamily="34" charset="0"/>
+                <a:ea typeface="Calibri" pitchFamily="34" charset="-122"/>
+                <a:cs typeface="Calibri" pitchFamily="34" charset="-120"/>
+              </a:rPr>
+              <a:t>regresión</a:t>
+            </a:r>
+            <a:r>
+              <a:rPr lang="en-US" sz="1200" i="1" dirty="0">
+                <a:solidFill>
+                  <a:srgbClr val="7A6F68"/>
+                </a:solidFill>
+                <a:latin typeface="Calibri" pitchFamily="34" charset="0"/>
+                <a:ea typeface="Calibri" pitchFamily="34" charset="-122"/>
+                <a:cs typeface="Calibri" pitchFamily="34" charset="-120"/>
+              </a:rPr>
+              <a:t>, R² = 0,59).</a:t>
             </a:r>
             <a:endParaRPr lang="en-US" sz="1200" dirty="0"/>
           </a:p>
@@ -23168,7 +23190,7 @@
               <a:t> y </a:t>
             </a:r>
             <a:r>
-              <a:rPr lang="en-US" sz="1450" b="1" i="1" dirty="0">
+              <a:rPr lang="en-US" sz="1450" b="1" i="1" dirty="0" err="1">
                 <a:solidFill>
                   <a:srgbClr val="2B2320"/>
                 </a:solidFill>
@@ -23176,7 +23198,7 @@
                 <a:ea typeface="Calibri" pitchFamily="34" charset="-122"/>
                 <a:cs typeface="Calibri" pitchFamily="34" charset="-120"/>
               </a:rPr>
-              <a:t>provincial</a:t>
+              <a:t>provincia</a:t>
             </a:r>
             <a:r>
               <a:rPr lang="en-US" sz="1450" b="1" dirty="0">

</xml_diff>

<commit_message>
feat: Add vídeo respaldo App Web
</commit_message>
<xml_diff>
--- a/TFG_Chollos/Presentacion_Defensa_TFG.pptx
+++ b/TFG_Chollos/Presentacion_Defensa_TFG.pptx
@@ -23881,6 +23881,220 @@
           </a:p>
         </p:txBody>
       </p:sp>
+      <p:sp>
+        <p:nvSpPr>
+          <p:cNvPr id="15" name="Shape 6">
+            <a:extLst>
+              <a:ext uri="{FF2B5EF4-FFF2-40B4-BE49-F238E27FC236}">
+                <a16:creationId xmlns:a16="http://schemas.microsoft.com/office/drawing/2014/main" id="{6513E10D-C228-8FC2-6BA5-4F2DF2D84FBD}"/>
+              </a:ext>
+            </a:extLst>
+          </p:cNvPr>
+          <p:cNvSpPr/>
+          <p:nvPr/>
+        </p:nvSpPr>
+        <p:spPr>
+          <a:xfrm>
+            <a:off x="6245352" y="4709160"/>
+            <a:ext cx="5394960" cy="960120"/>
+          </a:xfrm>
+          <a:prstGeom prst="roundRect">
+            <a:avLst>
+              <a:gd name="adj" fmla="val 5161"/>
+            </a:avLst>
+          </a:prstGeom>
+          <a:solidFill>
+            <a:schemeClr val="accent1">
+              <a:lumMod val="20000"/>
+              <a:lumOff val="80000"/>
+            </a:schemeClr>
+          </a:solidFill>
+          <a:ln/>
+        </p:spPr>
+        <p:txBody>
+          <a:bodyPr/>
+          <a:lstStyle/>
+          <a:p>
+            <a:endParaRPr dirty="0"/>
+          </a:p>
+        </p:txBody>
+      </p:sp>
+      <p:sp>
+        <p:nvSpPr>
+          <p:cNvPr id="16" name="Shape 7">
+            <a:extLst>
+              <a:ext uri="{FF2B5EF4-FFF2-40B4-BE49-F238E27FC236}">
+                <a16:creationId xmlns:a16="http://schemas.microsoft.com/office/drawing/2014/main" id="{EEC70DE6-EA77-7973-0FD4-F1DC7EF04DF8}"/>
+              </a:ext>
+            </a:extLst>
+          </p:cNvPr>
+          <p:cNvSpPr/>
+          <p:nvPr/>
+        </p:nvSpPr>
+        <p:spPr>
+          <a:xfrm>
+            <a:off x="6501384" y="4965192"/>
+            <a:ext cx="548640" cy="548640"/>
+          </a:xfrm>
+          <a:prstGeom prst="ellipse">
+            <a:avLst/>
+          </a:prstGeom>
+          <a:solidFill>
+            <a:srgbClr val="D99A3D"/>
+          </a:solidFill>
+          <a:ln/>
+        </p:spPr>
+        <p:txBody>
+          <a:bodyPr/>
+          <a:lstStyle/>
+          <a:p>
+            <a:endParaRPr/>
+          </a:p>
+        </p:txBody>
+      </p:sp>
+      <p:sp>
+        <p:nvSpPr>
+          <p:cNvPr id="18" name="Text 8">
+            <a:extLst>
+              <a:ext uri="{FF2B5EF4-FFF2-40B4-BE49-F238E27FC236}">
+                <a16:creationId xmlns:a16="http://schemas.microsoft.com/office/drawing/2014/main" id="{F9EA4143-AABE-9ACA-A489-8B16185C03D5}"/>
+              </a:ext>
+            </a:extLst>
+          </p:cNvPr>
+          <p:cNvSpPr/>
+          <p:nvPr/>
+        </p:nvSpPr>
+        <p:spPr>
+          <a:xfrm>
+            <a:off x="7205472" y="4846320"/>
+            <a:ext cx="4297680" cy="320040"/>
+          </a:xfrm>
+          <a:prstGeom prst="rect">
+            <a:avLst/>
+          </a:prstGeom>
+          <a:noFill/>
+          <a:ln/>
+        </p:spPr>
+        <p:txBody>
+          <a:bodyPr wrap="square" lIns="0" tIns="0" rIns="0" bIns="0" rtlCol="0" anchor="ctr"/>
+          <a:lstStyle/>
+          <a:p>
+            <a:pPr marL="0" indent="0">
+              <a:buNone/>
+            </a:pPr>
+            <a:r>
+              <a:rPr lang="en-US" sz="1300" b="1" dirty="0" err="1">
+                <a:latin typeface="Calibri" pitchFamily="34" charset="0"/>
+                <a:ea typeface="Calibri" pitchFamily="34" charset="-122"/>
+                <a:cs typeface="Calibri" pitchFamily="34" charset="-120"/>
+              </a:rPr>
+              <a:t>Vídeo</a:t>
+            </a:r>
+            <a:r>
+              <a:rPr lang="en-US" sz="1300" b="1" dirty="0">
+                <a:latin typeface="Calibri" pitchFamily="34" charset="0"/>
+                <a:ea typeface="Calibri" pitchFamily="34" charset="-122"/>
+                <a:cs typeface="Calibri" pitchFamily="34" charset="-120"/>
+              </a:rPr>
+              <a:t> de </a:t>
+            </a:r>
+            <a:r>
+              <a:rPr lang="en-US" sz="1300" b="1" dirty="0" err="1">
+                <a:latin typeface="Calibri" pitchFamily="34" charset="0"/>
+                <a:ea typeface="Calibri" pitchFamily="34" charset="-122"/>
+                <a:cs typeface="Calibri" pitchFamily="34" charset="-120"/>
+              </a:rPr>
+              <a:t>respaldo</a:t>
+            </a:r>
+            <a:r>
+              <a:rPr lang="en-US" sz="1300" b="1" dirty="0">
+                <a:latin typeface="Calibri" pitchFamily="34" charset="0"/>
+                <a:ea typeface="Calibri" pitchFamily="34" charset="-122"/>
+                <a:cs typeface="Calibri" pitchFamily="34" charset="-120"/>
+              </a:rPr>
+              <a:t> de la App Web</a:t>
+            </a:r>
+            <a:endParaRPr lang="en-US" sz="1300" dirty="0"/>
+          </a:p>
+        </p:txBody>
+      </p:sp>
+      <p:sp>
+        <p:nvSpPr>
+          <p:cNvPr id="19" name="Text 9">
+            <a:hlinkClick r:id="rId6"/>
+            <a:extLst>
+              <a:ext uri="{FF2B5EF4-FFF2-40B4-BE49-F238E27FC236}">
+                <a16:creationId xmlns:a16="http://schemas.microsoft.com/office/drawing/2014/main" id="{1CB2A5E9-5F50-9654-C2E3-6E3557456271}"/>
+              </a:ext>
+            </a:extLst>
+          </p:cNvPr>
+          <p:cNvSpPr/>
+          <p:nvPr/>
+        </p:nvSpPr>
+        <p:spPr>
+          <a:xfrm>
+            <a:off x="7205472" y="5148072"/>
+            <a:ext cx="4297680" cy="228600"/>
+          </a:xfrm>
+          <a:prstGeom prst="rect">
+            <a:avLst/>
+          </a:prstGeom>
+          <a:noFill/>
+          <a:ln/>
+        </p:spPr>
+        <p:txBody>
+          <a:bodyPr wrap="square" lIns="0" tIns="0" rIns="0" bIns="0" rtlCol="0" anchor="t"/>
+          <a:lstStyle/>
+          <a:p>
+            <a:pPr marL="0" indent="0">
+              <a:buNone/>
+            </a:pPr>
+            <a:r>
+              <a:rPr lang="en-US" sz="1000" dirty="0">
+                <a:hlinkClick r:id="rId7"/>
+              </a:rPr>
+              <a:t>Home · </a:t>
+            </a:r>
+            <a:r>
+              <a:rPr lang="en-US" sz="1000" dirty="0" err="1">
+                <a:hlinkClick r:id="rId7"/>
+              </a:rPr>
+              <a:t>Streamlit</a:t>
+            </a:r>
+            <a:r>
+              <a:rPr lang="en-US" sz="1000" dirty="0">
+                <a:hlinkClick r:id="rId7"/>
+              </a:rPr>
+              <a:t> - Personal_ Microsoft​ Edge 2026-07-21 20-58-33.mp4 - Google Drive</a:t>
+            </a:r>
+            <a:endParaRPr lang="en-US" sz="1000" dirty="0"/>
+          </a:p>
+        </p:txBody>
+      </p:sp>
+      <p:pic>
+        <p:nvPicPr>
+          <p:cNvPr id="20" name="Picture 19" descr="video_icon.png"/>
+          <p:cNvPicPr>
+            <a:picLocks noChangeAspect="1"/>
+          </p:cNvPicPr>
+          <p:nvPr/>
+        </p:nvPicPr>
+        <p:blipFill>
+          <a:blip r:embed="rId8"/>
+          <a:stretch>
+            <a:fillRect/>
+          </a:stretch>
+        </p:blipFill>
+        <p:spPr>
+          <a:xfrm>
+            <a:off x="6638544" y="5102352"/>
+            <a:ext cx="274320" cy="274320"/>
+          </a:xfrm>
+          <a:prstGeom prst="rect">
+            <a:avLst/>
+          </a:prstGeom>
+        </p:spPr>
+      </p:pic>
     </p:spTree>
   </p:cSld>
   <p:clrMapOvr>

</xml_diff>